<commit_message>
docs: add the CGLIB subclass slide to the talk
After the self-invocation slide, a comparison answers the question it always raises: Spring proxies classes with no interface by generating a subclass of them. The same slide explains what rewrites @Configuration classes, which is the limitation this container documents with a test.
</commit_message>
<xml_diff>
--- a/docs/presentation/minispring-talk.pptx
+++ b/docs/presentation/minispring-talk.pptx
@@ -43,9 +43,10 @@
     <p:sldId id="291" r:id="rId37"/>
     <p:sldId id="292" r:id="rId38"/>
     <p:sldId id="293" r:id="rId39"/>
+    <p:sldId id="294" r:id="rId40"/>
   </p:sldIdLst>
   <p:notesMasterIdLst>
-    <p:notesMasterId r:id="rId40"/>
+    <p:notesMasterId r:id="rId41"/>
   </p:notesMasterIdLst>
   <p:sldSz cx="9144000" cy="5143500"/>
   <p:notesSz cx="5143500" cy="9144000"/>
@@ -2426,9 +2427,11 @@
           <a:p>
             <a:r>
               <a:rPr lang="en-US" dirty="0"/>
-              <a:t>Recap slide. Walk it once, quickly, naming the annotation that matters at each step.
-The insight worth stating: post-processing comes after @PostConstruct, so a proxy always wraps a fully initialised object. And @PreDestroy runs on the raw bean, because a JDK proxy only exposes interface methods.
-If you are running late, this is the slide to skip — it repeats what they just saw.</a:t>
+              <a:t>This slide answers the question someone always asks after the proxy section: Spring proxies classes that have no interface, so how?
+Explain the mechanism in one sentence: CGLIB writes a new class that extends yours and overrides every method to call the interceptor first.
+Then the consequences, in order: no interface needed; a final class or a final, private or static method is silently never intercepted; getBean on the implementation class works because the proxy really is one; and the proxy is built without calling your constructor, using Objenesis, so its own fields stay null — it is only a switchboard in front of the real bean.
+The line that ties the talk together is the callout: this is also what rewrites @Configuration classes, which is exactly the limitation my container documents with a test.
+Three facts for questions: CGLIB has been repackaged inside spring-core since Spring 3.2, so it is not a dependency you add; it is built on ASM; and it does not work in a GraalVM native image, which is part of why Spring 6 introduced AOT processing.</a:t>
             </a:r>
             <a:endParaRPr lang="en-US" dirty="0"/>
           </a:p>
@@ -2606,8 +2609,9 @@
           <a:p>
             <a:r>
               <a:rPr lang="en-US" dirty="0"/>
-              <a:t>Transition. Eight minutes. This is the part that converts spectators into people who will try it tonight.
-If the room is with you, do it live in the IDE. If not, the three slides are enough.</a:t>
+              <a:t>Recap slide. Walk it once, quickly, naming the annotation that matters at each step.
+The insight worth stating: post-processing comes after @PostConstruct, so a proxy always wraps a fully initialised object. And @PreDestroy runs on the raw bean, because a JDK proxy only exposes interface methods.
+If you are running late, this is the slide to skip — it repeats what they just saw.</a:t>
             </a:r>
             <a:endParaRPr lang="en-US" dirty="0"/>
           </a:p>
@@ -2695,9 +2699,8 @@
           <a:p>
             <a:r>
               <a:rPr lang="en-US" dirty="0"/>
-              <a:t>DEMO if possible. Write the annotation, copy TransactionalProcessor, rename, run the test. Five minutes, rehearsed.
-The sentence to land: every method-level annotation in Spring works this way. @Cacheable, @Retry, @Async, @PreAuthorize — same pattern, more edge cases.
-Then warn them, honestly: in real projects, use the existing ones. The point is not to rewrite Spring, it is to stop being afraid of it.</a:t>
+              <a:t>Transition. Eight minutes. This is the part that converts spectators into people who will try it tonight.
+If the room is with you, do it live in the IDE. If not, the three slides are enough.</a:t>
             </a:r>
             <a:endParaRPr lang="en-US" dirty="0"/>
           </a:p>
@@ -2785,7 +2788,9 @@
           <a:p>
             <a:r>
               <a:rPr lang="en-US" dirty="0"/>
-              <a:t>Transition. Six minutes. Tell the true story: this part exists because someone asked the question in a LinkedIn comment. It makes the talk feel alive, and it invites questions.</a:t>
+              <a:t>DEMO if possible. Write the annotation, copy TransactionalProcessor, rename, run the test. Five minutes, rehearsed.
+The sentence to land: every method-level annotation in Spring works this way. @Cacheable, @Retry, @Async, @PreAuthorize — same pattern, more edge cases.
+Then warn them, honestly: in real projects, use the existing ones. The point is not to rewrite Spring, it is to stop being afraid of it.</a:t>
             </a:r>
             <a:endParaRPr lang="en-US" dirty="0"/>
           </a:p>
@@ -2873,9 +2878,7 @@
           <a:p>
             <a:r>
               <a:rPr lang="en-US" dirty="0"/>
-              <a:t>Walk the four boxes. Insist on the first one: your beans are registered first. Everything else depends on that ordering.
-Say what auto-configuration is in one sentence: a plugin that contributes bean definitions through an extension point, after you, and only for what is missing.
-In my implementation the container knows nothing about it: it is a separate module, 300 lines.</a:t>
+              <a:t>Transition. Six minutes. Tell the true story: this part exists because someone asked the question in a LinkedIn comment. It makes the talk feel alive, and it invites questions.</a:t>
             </a:r>
             <a:endParaRPr lang="en-US" dirty="0"/>
           </a:p>
@@ -2963,9 +2966,9 @@
           <a:p>
             <a:r>
               <a:rPr lang="en-US" dirty="0"/>
-              <a:t>These two rules are the answer to Karim's question, and the takeaway of the whole section.
-Rule two explains the warning in Spring's own documentation: @ConditionalOnMissingBean is only reliable inside an auto-configuration. Now they know why, instead of just obeying.
-Bolt: @ConditionalOnClass has to name classes as strings in my version, because reading a Class attribute that points at an absent class fails — which is exactly the case it exists for. Spring solves it by reading annotations from the bytecode with ASM. One constraint, and a dependency people never question suddenly makes sense.</a:t>
+              <a:t>Walk the four boxes. Insist on the first one: your beans are registered first. Everything else depends on that ordering.
+Say what auto-configuration is in one sentence: a plugin that contributes bean definitions through an extension point, after you, and only for what is missing.
+In my implementation the container knows nothing about it: it is a separate module, 300 lines.</a:t>
             </a:r>
             <a:endParaRPr lang="en-US" dirty="0"/>
           </a:p>
@@ -3053,9 +3056,9 @@
           <a:p>
             <a:r>
               <a:rPr lang="en-US" dirty="0"/>
-              <a:t>This is the practical takeaway people can use on Monday morning, whatever framework they run.
-Say it plainly: most developers debug auto-configuration by guessing. The report turns guessing into reading.
-Demo option: run the three-scenario demo from the repository. Default bean, your own bean, starter switched off. Ninety seconds.</a:t>
+              <a:t>These two rules are the answer to Karim's question, and the takeaway of the whole section.
+Rule two explains the warning in Spring's own documentation: @ConditionalOnMissingBean is only reliable inside an auto-configuration. Now they know why, instead of just obeying.
+Bolt: @ConditionalOnClass has to name classes as strings in my version, because reading a Class attribute that points at an absent class fails — which is exactly the case it exists for. Spring solves it by reading annotations from the bytecode with ASM. One constraint, and a dependency people never question suddenly makes sense.</a:t>
             </a:r>
             <a:endParaRPr lang="en-US" dirty="0"/>
           </a:p>
@@ -3143,7 +3146,9 @@
           <a:p>
             <a:r>
               <a:rPr lang="en-US" dirty="0"/>
-              <a:t>Transition. Three minutes. Never end a rebuild talk on a victory lap — the audience knows Spring does infinitely more. Owning that is what makes the rest credible.</a:t>
+              <a:t>This is the practical takeaway people can use on Monday morning, whatever framework they run.
+Say it plainly: most developers debug auto-configuration by guessing. The report turns guessing into reading.
+Demo option: run the three-scenario demo from the repository. Default bean, your own bean, starter switched off. Ninety seconds.</a:t>
             </a:r>
             <a:endParaRPr lang="en-US" dirty="0"/>
           </a:p>
@@ -3231,9 +3236,7 @@
           <a:p>
             <a:r>
               <a:rPr lang="en-US" dirty="0"/>
-              <a:t>Deliver this without irony. The audience includes people who maintain large Spring applications; respect that.
-If someone asks how to make Spring Boot start faster: lazy initialisation, fewer starters, and AOT with native images. Say it in one sentence, do not start a second talk.
-Also own my own limitations here: constructor injection only, JDK proxies only, no jar scanning, not thread-safe during startup. They are choices, and they are in the README.</a:t>
+              <a:t>Transition. Three minutes. Never end a rebuild talk on a victory lap — the audience knows Spring does infinitely more. Owning that is what makes the rest credible.</a:t>
             </a:r>
             <a:endParaRPr lang="en-US" dirty="0"/>
           </a:p>
@@ -3321,9 +3324,9 @@
           <a:p>
             <a:r>
               <a:rPr lang="en-US" dirty="0"/>
-              <a:t>Close on the three sentences, then stop talking. Do not add a fourth point.
-The call to action that works: clone it and read the commit history in order, each commit adds one concept with its tests.
-Then open the floor. Expected questions: why no CGLIB; how do cycles work; is it production-ready (no, and say so); how long did it take.</a:t>
+              <a:t>Deliver this without irony. The audience includes people who maintain large Spring applications; respect that.
+If someone asks how to make Spring Boot start faster: lazy initialisation, fewer starters, and AOT with native images. Say it in one sentence, do not start a second talk.
+Also own my own limitations here: constructor injection only, JDK proxies only, no jar scanning, not thread-safe during startup. They are choices, and they are in the README.</a:t>
             </a:r>
             <a:endParaRPr lang="en-US" dirty="0"/>
           </a:p>
@@ -3347,6 +3350,96 @@
             <a:fld id="{F7021451-1387-4CA6-816F-3879F97B5CBC}" type="slidenum">
               <a:rPr lang="en-US"/>
               <a:t>38</a:t>
+            </a:fld>
+            <a:endParaRPr lang="en-US"/>
+          </a:p>
+        </p:txBody>
+      </p:sp>
+    </p:spTree>
+    <p:extLst>
+      <p:ext uri="{BB962C8B-B14F-4D97-AF65-F5344CB8AC3E}">
+        <p14:creationId xmlns:p14="http://schemas.microsoft.com/office/powerpoint/2010/main" val="1024086991"/>
+      </p:ext>
+    </p:extLst>
+  </p:cSld>
+  <p:clrMapOvr>
+    <a:masterClrMapping/>
+  </p:clrMapOvr>
+</p:notes>
+</file>
+
+<file path=ppt/notesSlides/notesSlide39.xml><?xml version="1.0" encoding="utf-8"?>
+<p:notes xmlns:a="http://schemas.openxmlformats.org/drawingml/2006/main" xmlns:r="http://schemas.openxmlformats.org/officeDocument/2006/relationships" xmlns:p="http://schemas.openxmlformats.org/presentationml/2006/main">
+  <p:cSld>
+    <p:spTree>
+      <p:nvGrpSpPr>
+        <p:cNvPr id="1" name=""/>
+        <p:cNvGrpSpPr/>
+        <p:nvPr/>
+      </p:nvGrpSpPr>
+      <p:grpSpPr>
+        <a:xfrm>
+          <a:off x="0" y="0"/>
+          <a:ext cx="0" cy="0"/>
+          <a:chOff x="0" y="0"/>
+          <a:chExt cx="0" cy="0"/>
+        </a:xfrm>
+      </p:grpSpPr>
+      <p:sp>
+        <p:nvSpPr>
+          <p:cNvPr id="2" name="Slide Image Placeholder 1"/>
+          <p:cNvSpPr>
+            <a:spLocks noGrp="1" noRot="1" noChangeAspect="1"/>
+          </p:cNvSpPr>
+          <p:nvPr>
+            <p:ph type="sldImg"/>
+          </p:nvPr>
+        </p:nvSpPr>
+        <p:spPr/>
+      </p:sp>
+      <p:sp>
+        <p:nvSpPr>
+          <p:cNvPr id="3" name="Notes Placeholder 2"/>
+          <p:cNvSpPr>
+            <a:spLocks noGrp="1"/>
+          </p:cNvSpPr>
+          <p:nvPr>
+            <p:ph type="body" idx="1"/>
+          </p:nvPr>
+        </p:nvSpPr>
+        <p:spPr/>
+        <p:txBody>
+          <a:bodyPr/>
+          <a:lstStyle/>
+          <a:p>
+            <a:r>
+              <a:rPr lang="en-US" dirty="0"/>
+              <a:t>Close on the three sentences, then stop talking. Do not add a fourth point.
+The call to action that works: clone it and read the commit history in order, each commit adds one concept with its tests.
+Then open the floor. Expected questions: why no CGLIB; how do cycles work; is it production-ready (no, and say so); how long did it take.</a:t>
+            </a:r>
+            <a:endParaRPr lang="en-US" dirty="0"/>
+          </a:p>
+        </p:txBody>
+      </p:sp>
+      <p:sp>
+        <p:nvSpPr>
+          <p:cNvPr id="4" name="Slide Number Placeholder 3"/>
+          <p:cNvSpPr>
+            <a:spLocks noGrp="1"/>
+          </p:cNvSpPr>
+          <p:nvPr>
+            <p:ph type="sldNum" sz="quarter" idx="10"/>
+          </p:nvPr>
+        </p:nvSpPr>
+        <p:spPr/>
+        <p:txBody>
+          <a:bodyPr/>
+          <a:lstStyle/>
+          <a:p>
+            <a:fld id="{F7021451-1387-4CA6-816F-3879F97B5CBC}" type="slidenum">
+              <a:rPr lang="en-US"/>
+              <a:t>39</a:t>
             </a:fld>
             <a:endParaRPr lang="en-US"/>
           </a:p>
@@ -19111,6 +19204,1835 @@
           <a:chExt cx="0" cy="0"/>
         </a:xfrm>
       </p:grpSpPr>
+      <p:sp>
+        <p:nvSpPr>
+          <p:cNvPr id="2" name="Text 0"/>
+          <p:cNvSpPr txBox="1"/>
+          <p:nvPr/>
+        </p:nvSpPr>
+        <p:spPr>
+          <a:xfrm>
+            <a:off x="457200" y="292608"/>
+            <a:ext cx="8229600" cy="713232"/>
+          </a:xfrm>
+          <a:prstGeom prst="rect">
+            <a:avLst/>
+          </a:prstGeom>
+          <a:noFill/>
+          <a:ln/>
+        </p:spPr>
+        <p:txBody>
+          <a:bodyPr wrap="square" lIns="0" tIns="0" rIns="0" bIns="0" rtlCol="0" anchor="t"/>
+          <a:lstStyle/>
+          <a:p>
+            <a:pPr indent="0" marL="0">
+              <a:buNone/>
+            </a:pPr>
+            <a:r>
+              <a:rPr lang="en-US" sz="2600" b="1" dirty="0">
+                <a:solidFill>
+                  <a:srgbClr val="22303C"/>
+                </a:solidFill>
+                <a:latin typeface="Cambria" pitchFamily="34" charset="0"/>
+                <a:ea typeface="Cambria" pitchFamily="34" charset="-122"/>
+                <a:cs typeface="Cambria" pitchFamily="34" charset="-120"/>
+              </a:rPr>
+              <a:t>Spring's other proxy: a generated subclass</a:t>
+            </a:r>
+            <a:endParaRPr lang="en-US" sz="2600" dirty="0"/>
+          </a:p>
+        </p:txBody>
+      </p:sp>
+      <p:sp>
+        <p:nvSpPr>
+          <p:cNvPr id="3" name="Text 1"/>
+          <p:cNvSpPr txBox="1"/>
+          <p:nvPr/>
+        </p:nvSpPr>
+        <p:spPr>
+          <a:xfrm>
+            <a:off x="457200" y="987552"/>
+            <a:ext cx="8229600" cy="292608"/>
+          </a:xfrm>
+          <a:prstGeom prst="rect">
+            <a:avLst/>
+          </a:prstGeom>
+          <a:noFill/>
+          <a:ln/>
+        </p:spPr>
+        <p:txBody>
+          <a:bodyPr wrap="square" lIns="0" tIns="0" rIns="0" bIns="0" rtlCol="0" anchor="ctr"/>
+          <a:lstStyle/>
+          <a:p>
+            <a:pPr indent="0" marL="0">
+              <a:buNone/>
+            </a:pPr>
+            <a:r>
+              <a:rPr lang="en-US" sz="1500" dirty="0">
+                <a:solidFill>
+                  <a:srgbClr val="5B6B7A"/>
+                </a:solidFill>
+                <a:latin typeface="Calibri" pitchFamily="34" charset="0"/>
+                <a:ea typeface="Calibri" pitchFamily="34" charset="-122"/>
+                <a:cs typeface="Calibri" pitchFamily="34" charset="-120"/>
+              </a:rPr>
+              <a:t>Same idea, different trick — and it is what makes @Configuration work</a:t>
+            </a:r>
+            <a:endParaRPr lang="en-US" sz="1500" dirty="0"/>
+          </a:p>
+        </p:txBody>
+      </p:sp>
+      <p:sp>
+        <p:nvSpPr>
+          <p:cNvPr id="4" name="Shape 2"/>
+          <p:cNvSpPr/>
+          <p:nvPr/>
+        </p:nvSpPr>
+        <p:spPr>
+          <a:xfrm>
+            <a:off x="457200" y="1371600"/>
+            <a:ext cx="8229600" cy="548640"/>
+          </a:xfrm>
+          <a:prstGeom prst="roundRect">
+            <a:avLst>
+              <a:gd name="adj" fmla="val 10000"/>
+            </a:avLst>
+          </a:prstGeom>
+          <a:solidFill>
+            <a:srgbClr val="F1F3F5"/>
+          </a:solidFill>
+          <a:ln w="12700">
+            <a:solidFill>
+              <a:srgbClr val="DEE2E6"/>
+            </a:solidFill>
+            <a:prstDash val="solid"/>
+          </a:ln>
+        </p:spPr>
+      </p:sp>
+      <p:sp>
+        <p:nvSpPr>
+          <p:cNvPr id="5" name="Text 3"/>
+          <p:cNvSpPr txBox="1"/>
+          <p:nvPr/>
+        </p:nvSpPr>
+        <p:spPr>
+          <a:xfrm>
+            <a:off x="621792" y="1481328"/>
+            <a:ext cx="7900416" cy="329184"/>
+          </a:xfrm>
+          <a:prstGeom prst="rect">
+            <a:avLst/>
+          </a:prstGeom>
+          <a:noFill/>
+          <a:ln/>
+        </p:spPr>
+        <p:txBody>
+          <a:bodyPr wrap="square" lIns="0" tIns="0" rIns="0" bIns="0" rtlCol="0" anchor="ctr"/>
+          <a:lstStyle/>
+          <a:p>
+            <a:pPr indent="0" marL="0">
+              <a:lnSpc>
+                <a:spcPct val="115000"/>
+              </a:lnSpc>
+              <a:buNone/>
+            </a:pPr>
+            <a:r>
+              <a:rPr lang="en-US" sz="1300" dirty="0">
+                <a:solidFill>
+                  <a:srgbClr val="22303C"/>
+                </a:solidFill>
+                <a:latin typeface="Courier New" pitchFamily="34" charset="0"/>
+                <a:ea typeface="Courier New" pitchFamily="34" charset="-122"/>
+                <a:cs typeface="Courier New" pitchFamily="34" charset="-120"/>
+              </a:rPr>
+              <a:t>OrderServiceImpl$$SpringCGLIB$$0  extends  OrderServiceImpl</a:t>
+            </a:r>
+            <a:endParaRPr lang="en-US" sz="1300" dirty="0"/>
+          </a:p>
+        </p:txBody>
+      </p:sp>
+      <p:graphicFrame>
+        <p:nvGraphicFramePr>
+          <p:cNvPr id="30" name="Table 0"/>
+          <p:cNvGraphicFramePr>
+            <a:graphicFrameLocks noGrp="1"/>
+          </p:cNvGraphicFramePr>
+          <p:nvPr>
+            <p:extLst>
+              <p:ext uri="{D42A27DB-BD31-4B8C-83A1-F6EECF244321}">
+                <p14:modId xmlns:p14="http://schemas.microsoft.com/office/powerpoint/2010/main" val="1579011935"/>
+              </p:ext>
+            </p:extLst>
+          </p:nvPr>
+        </p:nvGraphicFramePr>
+        <p:xfrm>
+          <a:off x="457200" y="2057400"/>
+          <a:ext cx="8229600" cy="914400"/>
+        </p:xfrm>
+        <a:graphic>
+          <a:graphicData uri="http://schemas.openxmlformats.org/drawingml/2006/table">
+            <a:tbl>
+              <a:tblPr/>
+              <a:tblGrid>
+                <a:gridCol w="1737360"/>
+                <a:gridCol w="3108960"/>
+                <a:gridCol w="3383280"/>
+              </a:tblGrid>
+              <a:tr h="310896">
+                <a:tc>
+                  <a:txBody>
+                    <a:bodyPr/>
+                    <a:lstStyle/>
+                    <a:p>
+                      <a:pPr indent="0" marL="0">
+                        <a:buNone/>
+                      </a:pPr>
+                      <a:endParaRPr lang="en-US" sz="1200" dirty="0">
+                        <a:latin typeface="Calibri" charset="0"/>
+                        <a:ea typeface="Calibri" charset="0"/>
+                        <a:cs typeface="Calibri" charset="0"/>
+                      </a:endParaRPr>
+                    </a:p>
+                  </a:txBody>
+                  <a:tcPr marL="54864" marR="54864" marT="54864" marB="54864" anchor="ctr">
+                    <a:lnL w="12700" cap="flat" cmpd="sng" algn="ctr">
+                      <a:solidFill>
+                        <a:srgbClr val="E9ECEF"/>
+                      </a:solidFill>
+                      <a:prstDash val="solid"/>
+                      <a:round/>
+                      <a:headEnd type="none" w="med" len="med"/>
+                      <a:tailEnd type="none" w="med" len="med"/>
+                    </a:lnL>
+                    <a:lnR w="12700" cap="flat" cmpd="sng" algn="ctr">
+                      <a:solidFill>
+                        <a:srgbClr val="E9ECEF"/>
+                      </a:solidFill>
+                      <a:prstDash val="solid"/>
+                      <a:round/>
+                      <a:headEnd type="none" w="med" len="med"/>
+                      <a:tailEnd type="none" w="med" len="med"/>
+                    </a:lnR>
+                    <a:lnT w="12700" cap="flat" cmpd="sng" algn="ctr">
+                      <a:solidFill>
+                        <a:srgbClr val="E9ECEF"/>
+                      </a:solidFill>
+                      <a:prstDash val="solid"/>
+                      <a:round/>
+                      <a:headEnd type="none" w="med" len="med"/>
+                      <a:tailEnd type="none" w="med" len="med"/>
+                    </a:lnT>
+                    <a:lnB w="12700" cap="flat" cmpd="sng" algn="ctr">
+                      <a:solidFill>
+                        <a:srgbClr val="E9ECEF"/>
+                      </a:solidFill>
+                      <a:prstDash val="solid"/>
+                      <a:round/>
+                      <a:headEnd type="none" w="med" len="med"/>
+                      <a:tailEnd type="none" w="med" len="med"/>
+                    </a:lnB>
+                    <a:solidFill>
+                      <a:srgbClr val="2E3A47"/>
+                    </a:solidFill>
+                  </a:tcPr>
+                </a:tc>
+                <a:tc>
+                  <a:txBody>
+                    <a:bodyPr/>
+                    <a:lstStyle/>
+                    <a:p>
+                      <a:pPr indent="0" marL="0">
+                        <a:buNone/>
+                      </a:pPr>
+                      <a:r>
+                        <a:rPr lang="en-US" sz="1200" b="1" dirty="0">
+                          <a:solidFill>
+                            <a:srgbClr val="FFFFFF"/>
+                          </a:solidFill>
+                          <a:latin typeface="Calibri" pitchFamily="34" charset="0"/>
+                          <a:ea typeface="Calibri" pitchFamily="34" charset="-122"/>
+                          <a:cs typeface="Calibri" pitchFamily="34" charset="-120"/>
+                        </a:rPr>
+                        <a:t>JDK dynamic proxy (minispring)</a:t>
+                      </a:r>
+                      <a:endParaRPr lang="en-US" sz="1200" dirty="0">
+                        <a:latin typeface="Calibri" charset="0"/>
+                        <a:ea typeface="Calibri" charset="0"/>
+                        <a:cs typeface="Calibri" charset="0"/>
+                      </a:endParaRPr>
+                    </a:p>
+                  </a:txBody>
+                  <a:tcPr marL="54864" marR="54864" marT="54864" marB="54864" anchor="ctr">
+                    <a:lnL w="12700" cap="flat" cmpd="sng" algn="ctr">
+                      <a:solidFill>
+                        <a:srgbClr val="E9ECEF"/>
+                      </a:solidFill>
+                      <a:prstDash val="solid"/>
+                      <a:round/>
+                      <a:headEnd type="none" w="med" len="med"/>
+                      <a:tailEnd type="none" w="med" len="med"/>
+                    </a:lnL>
+                    <a:lnR w="12700" cap="flat" cmpd="sng" algn="ctr">
+                      <a:solidFill>
+                        <a:srgbClr val="E9ECEF"/>
+                      </a:solidFill>
+                      <a:prstDash val="solid"/>
+                      <a:round/>
+                      <a:headEnd type="none" w="med" len="med"/>
+                      <a:tailEnd type="none" w="med" len="med"/>
+                    </a:lnR>
+                    <a:lnT w="12700" cap="flat" cmpd="sng" algn="ctr">
+                      <a:solidFill>
+                        <a:srgbClr val="E9ECEF"/>
+                      </a:solidFill>
+                      <a:prstDash val="solid"/>
+                      <a:round/>
+                      <a:headEnd type="none" w="med" len="med"/>
+                      <a:tailEnd type="none" w="med" len="med"/>
+                    </a:lnT>
+                    <a:lnB w="12700" cap="flat" cmpd="sng" algn="ctr">
+                      <a:solidFill>
+                        <a:srgbClr val="E9ECEF"/>
+                      </a:solidFill>
+                      <a:prstDash val="solid"/>
+                      <a:round/>
+                      <a:headEnd type="none" w="med" len="med"/>
+                      <a:tailEnd type="none" w="med" len="med"/>
+                    </a:lnB>
+                    <a:solidFill>
+                      <a:srgbClr val="2E3A47"/>
+                    </a:solidFill>
+                  </a:tcPr>
+                </a:tc>
+                <a:tc>
+                  <a:txBody>
+                    <a:bodyPr/>
+                    <a:lstStyle/>
+                    <a:p>
+                      <a:pPr indent="0" marL="0">
+                        <a:buNone/>
+                      </a:pPr>
+                      <a:r>
+                        <a:rPr lang="en-US" sz="1200" b="1" dirty="0">
+                          <a:solidFill>
+                            <a:srgbClr val="FFFFFF"/>
+                          </a:solidFill>
+                          <a:latin typeface="Calibri" pitchFamily="34" charset="0"/>
+                          <a:ea typeface="Calibri" pitchFamily="34" charset="-122"/>
+                          <a:cs typeface="Calibri" pitchFamily="34" charset="-120"/>
+                        </a:rPr>
+                        <a:t>CGLIB subclass (Spring Boot default)</a:t>
+                      </a:r>
+                      <a:endParaRPr lang="en-US" sz="1200" dirty="0">
+                        <a:latin typeface="Calibri" charset="0"/>
+                        <a:ea typeface="Calibri" charset="0"/>
+                        <a:cs typeface="Calibri" charset="0"/>
+                      </a:endParaRPr>
+                    </a:p>
+                  </a:txBody>
+                  <a:tcPr marL="54864" marR="54864" marT="54864" marB="54864" anchor="ctr">
+                    <a:lnL w="12700" cap="flat" cmpd="sng" algn="ctr">
+                      <a:solidFill>
+                        <a:srgbClr val="E9ECEF"/>
+                      </a:solidFill>
+                      <a:prstDash val="solid"/>
+                      <a:round/>
+                      <a:headEnd type="none" w="med" len="med"/>
+                      <a:tailEnd type="none" w="med" len="med"/>
+                    </a:lnL>
+                    <a:lnR w="12700" cap="flat" cmpd="sng" algn="ctr">
+                      <a:solidFill>
+                        <a:srgbClr val="E9ECEF"/>
+                      </a:solidFill>
+                      <a:prstDash val="solid"/>
+                      <a:round/>
+                      <a:headEnd type="none" w="med" len="med"/>
+                      <a:tailEnd type="none" w="med" len="med"/>
+                    </a:lnR>
+                    <a:lnT w="12700" cap="flat" cmpd="sng" algn="ctr">
+                      <a:solidFill>
+                        <a:srgbClr val="E9ECEF"/>
+                      </a:solidFill>
+                      <a:prstDash val="solid"/>
+                      <a:round/>
+                      <a:headEnd type="none" w="med" len="med"/>
+                      <a:tailEnd type="none" w="med" len="med"/>
+                    </a:lnT>
+                    <a:lnB w="12700" cap="flat" cmpd="sng" algn="ctr">
+                      <a:solidFill>
+                        <a:srgbClr val="E9ECEF"/>
+                      </a:solidFill>
+                      <a:prstDash val="solid"/>
+                      <a:round/>
+                      <a:headEnd type="none" w="med" len="med"/>
+                      <a:tailEnd type="none" w="med" len="med"/>
+                    </a:lnB>
+                    <a:solidFill>
+                      <a:srgbClr val="2E3A47"/>
+                    </a:solidFill>
+                  </a:tcPr>
+                </a:tc>
+              </a:tr>
+              <a:tr h="310896">
+                <a:tc>
+                  <a:txBody>
+                    <a:bodyPr/>
+                    <a:lstStyle/>
+                    <a:p>
+                      <a:pPr indent="0" marL="0">
+                        <a:buNone/>
+                      </a:pPr>
+                      <a:r>
+                        <a:rPr lang="en-US" sz="1100" dirty="0">
+                          <a:solidFill>
+                            <a:srgbClr val="22303C"/>
+                          </a:solidFill>
+                          <a:latin typeface="Calibri" pitchFamily="34" charset="0"/>
+                          <a:ea typeface="Calibri" pitchFamily="34" charset="-122"/>
+                          <a:cs typeface="Calibri" pitchFamily="34" charset="-120"/>
+                        </a:rPr>
+                        <a:t>How</a:t>
+                      </a:r>
+                      <a:endParaRPr lang="en-US" sz="1100" dirty="0">
+                        <a:latin typeface="Calibri" charset="0"/>
+                        <a:ea typeface="Calibri" charset="0"/>
+                        <a:cs typeface="Calibri" charset="0"/>
+                      </a:endParaRPr>
+                    </a:p>
+                  </a:txBody>
+                  <a:tcPr marL="54864" marR="54864" marT="54864" marB="54864" anchor="ctr">
+                    <a:lnL w="12700" cap="flat" cmpd="sng" algn="ctr">
+                      <a:solidFill>
+                        <a:srgbClr val="E9ECEF"/>
+                      </a:solidFill>
+                      <a:prstDash val="solid"/>
+                      <a:round/>
+                      <a:headEnd type="none" w="med" len="med"/>
+                      <a:tailEnd type="none" w="med" len="med"/>
+                    </a:lnL>
+                    <a:lnR w="12700" cap="flat" cmpd="sng" algn="ctr">
+                      <a:solidFill>
+                        <a:srgbClr val="E9ECEF"/>
+                      </a:solidFill>
+                      <a:prstDash val="solid"/>
+                      <a:round/>
+                      <a:headEnd type="none" w="med" len="med"/>
+                      <a:tailEnd type="none" w="med" len="med"/>
+                    </a:lnR>
+                    <a:lnT w="12700" cap="flat" cmpd="sng" algn="ctr">
+                      <a:solidFill>
+                        <a:srgbClr val="E9ECEF"/>
+                      </a:solidFill>
+                      <a:prstDash val="solid"/>
+                      <a:round/>
+                      <a:headEnd type="none" w="med" len="med"/>
+                      <a:tailEnd type="none" w="med" len="med"/>
+                    </a:lnT>
+                    <a:lnB w="12700" cap="flat" cmpd="sng" algn="ctr">
+                      <a:solidFill>
+                        <a:srgbClr val="E9ECEF"/>
+                      </a:solidFill>
+                      <a:prstDash val="solid"/>
+                      <a:round/>
+                      <a:headEnd type="none" w="med" len="med"/>
+                      <a:tailEnd type="none" w="med" len="med"/>
+                    </a:lnB>
+                  </a:tcPr>
+                </a:tc>
+                <a:tc>
+                  <a:txBody>
+                    <a:bodyPr/>
+                    <a:lstStyle/>
+                    <a:p>
+                      <a:pPr indent="0" marL="0">
+                        <a:buNone/>
+                      </a:pPr>
+                      <a:r>
+                        <a:rPr lang="en-US" sz="1100" dirty="0">
+                          <a:solidFill>
+                            <a:srgbClr val="22303C"/>
+                          </a:solidFill>
+                          <a:latin typeface="Calibri" pitchFamily="34" charset="0"/>
+                          <a:ea typeface="Calibri" pitchFamily="34" charset="-122"/>
+                          <a:cs typeface="Calibri" pitchFamily="34" charset="-120"/>
+                        </a:rPr>
+                        <a:t>implements the interfaces</a:t>
+                      </a:r>
+                      <a:endParaRPr lang="en-US" sz="1100" dirty="0">
+                        <a:latin typeface="Calibri" charset="0"/>
+                        <a:ea typeface="Calibri" charset="0"/>
+                        <a:cs typeface="Calibri" charset="0"/>
+                      </a:endParaRPr>
+                    </a:p>
+                  </a:txBody>
+                  <a:tcPr marL="54864" marR="54864" marT="54864" marB="54864" anchor="ctr">
+                    <a:lnL w="12700" cap="flat" cmpd="sng" algn="ctr">
+                      <a:solidFill>
+                        <a:srgbClr val="E9ECEF"/>
+                      </a:solidFill>
+                      <a:prstDash val="solid"/>
+                      <a:round/>
+                      <a:headEnd type="none" w="med" len="med"/>
+                      <a:tailEnd type="none" w="med" len="med"/>
+                    </a:lnL>
+                    <a:lnR w="12700" cap="flat" cmpd="sng" algn="ctr">
+                      <a:solidFill>
+                        <a:srgbClr val="E9ECEF"/>
+                      </a:solidFill>
+                      <a:prstDash val="solid"/>
+                      <a:round/>
+                      <a:headEnd type="none" w="med" len="med"/>
+                      <a:tailEnd type="none" w="med" len="med"/>
+                    </a:lnR>
+                    <a:lnT w="12700" cap="flat" cmpd="sng" algn="ctr">
+                      <a:solidFill>
+                        <a:srgbClr val="E9ECEF"/>
+                      </a:solidFill>
+                      <a:prstDash val="solid"/>
+                      <a:round/>
+                      <a:headEnd type="none" w="med" len="med"/>
+                      <a:tailEnd type="none" w="med" len="med"/>
+                    </a:lnT>
+                    <a:lnB w="12700" cap="flat" cmpd="sng" algn="ctr">
+                      <a:solidFill>
+                        <a:srgbClr val="E9ECEF"/>
+                      </a:solidFill>
+                      <a:prstDash val="solid"/>
+                      <a:round/>
+                      <a:headEnd type="none" w="med" len="med"/>
+                      <a:tailEnd type="none" w="med" len="med"/>
+                    </a:lnB>
+                  </a:tcPr>
+                </a:tc>
+                <a:tc>
+                  <a:txBody>
+                    <a:bodyPr/>
+                    <a:lstStyle/>
+                    <a:p>
+                      <a:pPr indent="0" marL="0">
+                        <a:buNone/>
+                      </a:pPr>
+                      <a:r>
+                        <a:rPr lang="en-US" sz="1100" dirty="0">
+                          <a:solidFill>
+                            <a:srgbClr val="22303C"/>
+                          </a:solidFill>
+                          <a:latin typeface="Calibri" pitchFamily="34" charset="0"/>
+                          <a:ea typeface="Calibri" pitchFamily="34" charset="-122"/>
+                          <a:cs typeface="Calibri" pitchFamily="34" charset="-120"/>
+                        </a:rPr>
+                        <a:t>extends the class, overrides its methods</a:t>
+                      </a:r>
+                      <a:endParaRPr lang="en-US" sz="1100" dirty="0">
+                        <a:latin typeface="Calibri" charset="0"/>
+                        <a:ea typeface="Calibri" charset="0"/>
+                        <a:cs typeface="Calibri" charset="0"/>
+                      </a:endParaRPr>
+                    </a:p>
+                  </a:txBody>
+                  <a:tcPr marL="54864" marR="54864" marT="54864" marB="54864" anchor="ctr">
+                    <a:lnL w="12700" cap="flat" cmpd="sng" algn="ctr">
+                      <a:solidFill>
+                        <a:srgbClr val="E9ECEF"/>
+                      </a:solidFill>
+                      <a:prstDash val="solid"/>
+                      <a:round/>
+                      <a:headEnd type="none" w="med" len="med"/>
+                      <a:tailEnd type="none" w="med" len="med"/>
+                    </a:lnL>
+                    <a:lnR w="12700" cap="flat" cmpd="sng" algn="ctr">
+                      <a:solidFill>
+                        <a:srgbClr val="E9ECEF"/>
+                      </a:solidFill>
+                      <a:prstDash val="solid"/>
+                      <a:round/>
+                      <a:headEnd type="none" w="med" len="med"/>
+                      <a:tailEnd type="none" w="med" len="med"/>
+                    </a:lnR>
+                    <a:lnT w="12700" cap="flat" cmpd="sng" algn="ctr">
+                      <a:solidFill>
+                        <a:srgbClr val="E9ECEF"/>
+                      </a:solidFill>
+                      <a:prstDash val="solid"/>
+                      <a:round/>
+                      <a:headEnd type="none" w="med" len="med"/>
+                      <a:tailEnd type="none" w="med" len="med"/>
+                    </a:lnT>
+                    <a:lnB w="12700" cap="flat" cmpd="sng" algn="ctr">
+                      <a:solidFill>
+                        <a:srgbClr val="E9ECEF"/>
+                      </a:solidFill>
+                      <a:prstDash val="solid"/>
+                      <a:round/>
+                      <a:headEnd type="none" w="med" len="med"/>
+                      <a:tailEnd type="none" w="med" len="med"/>
+                    </a:lnB>
+                  </a:tcPr>
+                </a:tc>
+              </a:tr>
+              <a:tr h="310896">
+                <a:tc>
+                  <a:txBody>
+                    <a:bodyPr/>
+                    <a:lstStyle/>
+                    <a:p>
+                      <a:pPr indent="0" marL="0">
+                        <a:buNone/>
+                      </a:pPr>
+                      <a:r>
+                        <a:rPr lang="en-US" sz="1100" dirty="0">
+                          <a:solidFill>
+                            <a:srgbClr val="22303C"/>
+                          </a:solidFill>
+                          <a:latin typeface="Calibri" pitchFamily="34" charset="0"/>
+                          <a:ea typeface="Calibri" pitchFamily="34" charset="-122"/>
+                          <a:cs typeface="Calibri" pitchFamily="34" charset="-120"/>
+                        </a:rPr>
+                        <a:t>Requires</a:t>
+                      </a:r>
+                      <a:endParaRPr lang="en-US" sz="1100" dirty="0">
+                        <a:latin typeface="Calibri" charset="0"/>
+                        <a:ea typeface="Calibri" charset="0"/>
+                        <a:cs typeface="Calibri" charset="0"/>
+                      </a:endParaRPr>
+                    </a:p>
+                  </a:txBody>
+                  <a:tcPr marL="54864" marR="54864" marT="54864" marB="54864" anchor="ctr">
+                    <a:lnL w="12700" cap="flat" cmpd="sng" algn="ctr">
+                      <a:solidFill>
+                        <a:srgbClr val="E9ECEF"/>
+                      </a:solidFill>
+                      <a:prstDash val="solid"/>
+                      <a:round/>
+                      <a:headEnd type="none" w="med" len="med"/>
+                      <a:tailEnd type="none" w="med" len="med"/>
+                    </a:lnL>
+                    <a:lnR w="12700" cap="flat" cmpd="sng" algn="ctr">
+                      <a:solidFill>
+                        <a:srgbClr val="E9ECEF"/>
+                      </a:solidFill>
+                      <a:prstDash val="solid"/>
+                      <a:round/>
+                      <a:headEnd type="none" w="med" len="med"/>
+                      <a:tailEnd type="none" w="med" len="med"/>
+                    </a:lnR>
+                    <a:lnT w="12700" cap="flat" cmpd="sng" algn="ctr">
+                      <a:solidFill>
+                        <a:srgbClr val="E9ECEF"/>
+                      </a:solidFill>
+                      <a:prstDash val="solid"/>
+                      <a:round/>
+                      <a:headEnd type="none" w="med" len="med"/>
+                      <a:tailEnd type="none" w="med" len="med"/>
+                    </a:lnT>
+                    <a:lnB w="12700" cap="flat" cmpd="sng" algn="ctr">
+                      <a:solidFill>
+                        <a:srgbClr val="E9ECEF"/>
+                      </a:solidFill>
+                      <a:prstDash val="solid"/>
+                      <a:round/>
+                      <a:headEnd type="none" w="med" len="med"/>
+                      <a:tailEnd type="none" w="med" len="med"/>
+                    </a:lnB>
+                  </a:tcPr>
+                </a:tc>
+                <a:tc>
+                  <a:txBody>
+                    <a:bodyPr/>
+                    <a:lstStyle/>
+                    <a:p>
+                      <a:pPr indent="0" marL="0">
+                        <a:buNone/>
+                      </a:pPr>
+                      <a:r>
+                        <a:rPr lang="en-US" sz="1100" dirty="0">
+                          <a:solidFill>
+                            <a:srgbClr val="22303C"/>
+                          </a:solidFill>
+                          <a:latin typeface="Calibri" pitchFamily="34" charset="0"/>
+                          <a:ea typeface="Calibri" pitchFamily="34" charset="-122"/>
+                          <a:cs typeface="Calibri" pitchFamily="34" charset="-120"/>
+                        </a:rPr>
+                        <a:t>an interface</a:t>
+                      </a:r>
+                      <a:endParaRPr lang="en-US" sz="1100" dirty="0">
+                        <a:latin typeface="Calibri" charset="0"/>
+                        <a:ea typeface="Calibri" charset="0"/>
+                        <a:cs typeface="Calibri" charset="0"/>
+                      </a:endParaRPr>
+                    </a:p>
+                  </a:txBody>
+                  <a:tcPr marL="54864" marR="54864" marT="54864" marB="54864" anchor="ctr">
+                    <a:lnL w="12700" cap="flat" cmpd="sng" algn="ctr">
+                      <a:solidFill>
+                        <a:srgbClr val="E9ECEF"/>
+                      </a:solidFill>
+                      <a:prstDash val="solid"/>
+                      <a:round/>
+                      <a:headEnd type="none" w="med" len="med"/>
+                      <a:tailEnd type="none" w="med" len="med"/>
+                    </a:lnL>
+                    <a:lnR w="12700" cap="flat" cmpd="sng" algn="ctr">
+                      <a:solidFill>
+                        <a:srgbClr val="E9ECEF"/>
+                      </a:solidFill>
+                      <a:prstDash val="solid"/>
+                      <a:round/>
+                      <a:headEnd type="none" w="med" len="med"/>
+                      <a:tailEnd type="none" w="med" len="med"/>
+                    </a:lnR>
+                    <a:lnT w="12700" cap="flat" cmpd="sng" algn="ctr">
+                      <a:solidFill>
+                        <a:srgbClr val="E9ECEF"/>
+                      </a:solidFill>
+                      <a:prstDash val="solid"/>
+                      <a:round/>
+                      <a:headEnd type="none" w="med" len="med"/>
+                      <a:tailEnd type="none" w="med" len="med"/>
+                    </a:lnT>
+                    <a:lnB w="12700" cap="flat" cmpd="sng" algn="ctr">
+                      <a:solidFill>
+                        <a:srgbClr val="E9ECEF"/>
+                      </a:solidFill>
+                      <a:prstDash val="solid"/>
+                      <a:round/>
+                      <a:headEnd type="none" w="med" len="med"/>
+                      <a:tailEnd type="none" w="med" len="med"/>
+                    </a:lnB>
+                  </a:tcPr>
+                </a:tc>
+                <a:tc>
+                  <a:txBody>
+                    <a:bodyPr/>
+                    <a:lstStyle/>
+                    <a:p>
+                      <a:pPr indent="0" marL="0">
+                        <a:buNone/>
+                      </a:pPr>
+                      <a:r>
+                        <a:rPr lang="en-US" sz="1100" dirty="0">
+                          <a:solidFill>
+                            <a:srgbClr val="22303C"/>
+                          </a:solidFill>
+                          <a:latin typeface="Calibri" pitchFamily="34" charset="0"/>
+                          <a:ea typeface="Calibri" pitchFamily="34" charset="-122"/>
+                          <a:cs typeface="Calibri" pitchFamily="34" charset="-120"/>
+                        </a:rPr>
+                        <a:t>a class and methods that are not final</a:t>
+                      </a:r>
+                      <a:endParaRPr lang="en-US" sz="1100" dirty="0">
+                        <a:latin typeface="Calibri" charset="0"/>
+                        <a:ea typeface="Calibri" charset="0"/>
+                        <a:cs typeface="Calibri" charset="0"/>
+                      </a:endParaRPr>
+                    </a:p>
+                  </a:txBody>
+                  <a:tcPr marL="54864" marR="54864" marT="54864" marB="54864" anchor="ctr">
+                    <a:lnL w="12700" cap="flat" cmpd="sng" algn="ctr">
+                      <a:solidFill>
+                        <a:srgbClr val="E9ECEF"/>
+                      </a:solidFill>
+                      <a:prstDash val="solid"/>
+                      <a:round/>
+                      <a:headEnd type="none" w="med" len="med"/>
+                      <a:tailEnd type="none" w="med" len="med"/>
+                    </a:lnL>
+                    <a:lnR w="12700" cap="flat" cmpd="sng" algn="ctr">
+                      <a:solidFill>
+                        <a:srgbClr val="E9ECEF"/>
+                      </a:solidFill>
+                      <a:prstDash val="solid"/>
+                      <a:round/>
+                      <a:headEnd type="none" w="med" len="med"/>
+                      <a:tailEnd type="none" w="med" len="med"/>
+                    </a:lnR>
+                    <a:lnT w="12700" cap="flat" cmpd="sng" algn="ctr">
+                      <a:solidFill>
+                        <a:srgbClr val="E9ECEF"/>
+                      </a:solidFill>
+                      <a:prstDash val="solid"/>
+                      <a:round/>
+                      <a:headEnd type="none" w="med" len="med"/>
+                      <a:tailEnd type="none" w="med" len="med"/>
+                    </a:lnT>
+                    <a:lnB w="12700" cap="flat" cmpd="sng" algn="ctr">
+                      <a:solidFill>
+                        <a:srgbClr val="E9ECEF"/>
+                      </a:solidFill>
+                      <a:prstDash val="solid"/>
+                      <a:round/>
+                      <a:headEnd type="none" w="med" len="med"/>
+                      <a:tailEnd type="none" w="med" len="med"/>
+                    </a:lnB>
+                  </a:tcPr>
+                </a:tc>
+              </a:tr>
+              <a:tr h="310896">
+                <a:tc>
+                  <a:txBody>
+                    <a:bodyPr/>
+                    <a:lstStyle/>
+                    <a:p>
+                      <a:pPr indent="0" marL="0">
+                        <a:buNone/>
+                      </a:pPr>
+                      <a:r>
+                        <a:rPr lang="en-US" sz="1100" dirty="0">
+                          <a:solidFill>
+                            <a:srgbClr val="22303C"/>
+                          </a:solidFill>
+                          <a:latin typeface="Courier New" pitchFamily="34" charset="0"/>
+                          <a:ea typeface="Courier New" pitchFamily="34" charset="-122"/>
+                          <a:cs typeface="Courier New" pitchFamily="34" charset="-120"/>
+                        </a:rPr>
+                        <a:t>getBean(Impl.class)</a:t>
+                      </a:r>
+                      <a:endParaRPr lang="en-US" sz="1100" dirty="0">
+                        <a:latin typeface="Courier New" charset="0"/>
+                        <a:ea typeface="Courier New" charset="0"/>
+                        <a:cs typeface="Courier New" charset="0"/>
+                      </a:endParaRPr>
+                    </a:p>
+                  </a:txBody>
+                  <a:tcPr marL="54864" marR="54864" marT="54864" marB="54864" anchor="ctr">
+                    <a:lnL w="12700" cap="flat" cmpd="sng" algn="ctr">
+                      <a:solidFill>
+                        <a:srgbClr val="E9ECEF"/>
+                      </a:solidFill>
+                      <a:prstDash val="solid"/>
+                      <a:round/>
+                      <a:headEnd type="none" w="med" len="med"/>
+                      <a:tailEnd type="none" w="med" len="med"/>
+                    </a:lnL>
+                    <a:lnR w="12700" cap="flat" cmpd="sng" algn="ctr">
+                      <a:solidFill>
+                        <a:srgbClr val="E9ECEF"/>
+                      </a:solidFill>
+                      <a:prstDash val="solid"/>
+                      <a:round/>
+                      <a:headEnd type="none" w="med" len="med"/>
+                      <a:tailEnd type="none" w="med" len="med"/>
+                    </a:lnR>
+                    <a:lnT w="12700" cap="flat" cmpd="sng" algn="ctr">
+                      <a:solidFill>
+                        <a:srgbClr val="E9ECEF"/>
+                      </a:solidFill>
+                      <a:prstDash val="solid"/>
+                      <a:round/>
+                      <a:headEnd type="none" w="med" len="med"/>
+                      <a:tailEnd type="none" w="med" len="med"/>
+                    </a:lnT>
+                    <a:lnB w="12700" cap="flat" cmpd="sng" algn="ctr">
+                      <a:solidFill>
+                        <a:srgbClr val="E9ECEF"/>
+                      </a:solidFill>
+                      <a:prstDash val="solid"/>
+                      <a:round/>
+                      <a:headEnd type="none" w="med" len="med"/>
+                      <a:tailEnd type="none" w="med" len="med"/>
+                    </a:lnB>
+                  </a:tcPr>
+                </a:tc>
+                <a:tc>
+                  <a:txBody>
+                    <a:bodyPr/>
+                    <a:lstStyle/>
+                    <a:p>
+                      <a:pPr indent="0" marL="0">
+                        <a:buNone/>
+                      </a:pPr>
+                      <a:r>
+                        <a:rPr lang="en-US" sz="1100" dirty="0">
+                          <a:solidFill>
+                            <a:srgbClr val="22303C"/>
+                          </a:solidFill>
+                          <a:latin typeface="Calibri" pitchFamily="34" charset="0"/>
+                          <a:ea typeface="Calibri" pitchFamily="34" charset="-122"/>
+                          <a:cs typeface="Calibri" pitchFamily="34" charset="-120"/>
+                        </a:rPr>
+                        <a:t>fails: the proxy is not that type</a:t>
+                      </a:r>
+                      <a:endParaRPr lang="en-US" sz="1100" dirty="0">
+                        <a:latin typeface="Calibri" charset="0"/>
+                        <a:ea typeface="Calibri" charset="0"/>
+                        <a:cs typeface="Calibri" charset="0"/>
+                      </a:endParaRPr>
+                    </a:p>
+                  </a:txBody>
+                  <a:tcPr marL="54864" marR="54864" marT="54864" marB="54864" anchor="ctr">
+                    <a:lnL w="12700" cap="flat" cmpd="sng" algn="ctr">
+                      <a:solidFill>
+                        <a:srgbClr val="E9ECEF"/>
+                      </a:solidFill>
+                      <a:prstDash val="solid"/>
+                      <a:round/>
+                      <a:headEnd type="none" w="med" len="med"/>
+                      <a:tailEnd type="none" w="med" len="med"/>
+                    </a:lnL>
+                    <a:lnR w="12700" cap="flat" cmpd="sng" algn="ctr">
+                      <a:solidFill>
+                        <a:srgbClr val="E9ECEF"/>
+                      </a:solidFill>
+                      <a:prstDash val="solid"/>
+                      <a:round/>
+                      <a:headEnd type="none" w="med" len="med"/>
+                      <a:tailEnd type="none" w="med" len="med"/>
+                    </a:lnR>
+                    <a:lnT w="12700" cap="flat" cmpd="sng" algn="ctr">
+                      <a:solidFill>
+                        <a:srgbClr val="E9ECEF"/>
+                      </a:solidFill>
+                      <a:prstDash val="solid"/>
+                      <a:round/>
+                      <a:headEnd type="none" w="med" len="med"/>
+                      <a:tailEnd type="none" w="med" len="med"/>
+                    </a:lnT>
+                    <a:lnB w="12700" cap="flat" cmpd="sng" algn="ctr">
+                      <a:solidFill>
+                        <a:srgbClr val="E9ECEF"/>
+                      </a:solidFill>
+                      <a:prstDash val="solid"/>
+                      <a:round/>
+                      <a:headEnd type="none" w="med" len="med"/>
+                      <a:tailEnd type="none" w="med" len="med"/>
+                    </a:lnB>
+                  </a:tcPr>
+                </a:tc>
+                <a:tc>
+                  <a:txBody>
+                    <a:bodyPr/>
+                    <a:lstStyle/>
+                    <a:p>
+                      <a:pPr indent="0" marL="0">
+                        <a:buNone/>
+                      </a:pPr>
+                      <a:r>
+                        <a:rPr lang="en-US" sz="1100" dirty="0">
+                          <a:solidFill>
+                            <a:srgbClr val="22303C"/>
+                          </a:solidFill>
+                          <a:latin typeface="Calibri" pitchFamily="34" charset="0"/>
+                          <a:ea typeface="Calibri" pitchFamily="34" charset="-122"/>
+                          <a:cs typeface="Calibri" pitchFamily="34" charset="-120"/>
+                        </a:rPr>
+                        <a:t>works: the proxy is a subclass</a:t>
+                      </a:r>
+                      <a:endParaRPr lang="en-US" sz="1100" dirty="0">
+                        <a:latin typeface="Calibri" charset="0"/>
+                        <a:ea typeface="Calibri" charset="0"/>
+                        <a:cs typeface="Calibri" charset="0"/>
+                      </a:endParaRPr>
+                    </a:p>
+                  </a:txBody>
+                  <a:tcPr marL="54864" marR="54864" marT="54864" marB="54864" anchor="ctr">
+                    <a:lnL w="12700" cap="flat" cmpd="sng" algn="ctr">
+                      <a:solidFill>
+                        <a:srgbClr val="E9ECEF"/>
+                      </a:solidFill>
+                      <a:prstDash val="solid"/>
+                      <a:round/>
+                      <a:headEnd type="none" w="med" len="med"/>
+                      <a:tailEnd type="none" w="med" len="med"/>
+                    </a:lnL>
+                    <a:lnR w="12700" cap="flat" cmpd="sng" algn="ctr">
+                      <a:solidFill>
+                        <a:srgbClr val="E9ECEF"/>
+                      </a:solidFill>
+                      <a:prstDash val="solid"/>
+                      <a:round/>
+                      <a:headEnd type="none" w="med" len="med"/>
+                      <a:tailEnd type="none" w="med" len="med"/>
+                    </a:lnR>
+                    <a:lnT w="12700" cap="flat" cmpd="sng" algn="ctr">
+                      <a:solidFill>
+                        <a:srgbClr val="E9ECEF"/>
+                      </a:solidFill>
+                      <a:prstDash val="solid"/>
+                      <a:round/>
+                      <a:headEnd type="none" w="med" len="med"/>
+                      <a:tailEnd type="none" w="med" len="med"/>
+                    </a:lnT>
+                    <a:lnB w="12700" cap="flat" cmpd="sng" algn="ctr">
+                      <a:solidFill>
+                        <a:srgbClr val="E9ECEF"/>
+                      </a:solidFill>
+                      <a:prstDash val="solid"/>
+                      <a:round/>
+                      <a:headEnd type="none" w="med" len="med"/>
+                      <a:tailEnd type="none" w="med" len="med"/>
+                    </a:lnB>
+                  </a:tcPr>
+                </a:tc>
+              </a:tr>
+              <a:tr h="310896">
+                <a:tc>
+                  <a:txBody>
+                    <a:bodyPr/>
+                    <a:lstStyle/>
+                    <a:p>
+                      <a:pPr indent="0" marL="0">
+                        <a:buNone/>
+                      </a:pPr>
+                      <a:r>
+                        <a:rPr lang="en-US" sz="1100" dirty="0">
+                          <a:solidFill>
+                            <a:srgbClr val="22303C"/>
+                          </a:solidFill>
+                          <a:latin typeface="Calibri" pitchFamily="34" charset="0"/>
+                          <a:ea typeface="Calibri" pitchFamily="34" charset="-122"/>
+                          <a:cs typeface="Calibri" pitchFamily="34" charset="-120"/>
+                        </a:rPr>
+                        <a:t>Built by</a:t>
+                      </a:r>
+                      <a:endParaRPr lang="en-US" sz="1100" dirty="0">
+                        <a:latin typeface="Calibri" charset="0"/>
+                        <a:ea typeface="Calibri" charset="0"/>
+                        <a:cs typeface="Calibri" charset="0"/>
+                      </a:endParaRPr>
+                    </a:p>
+                  </a:txBody>
+                  <a:tcPr marL="54864" marR="54864" marT="54864" marB="54864" anchor="ctr">
+                    <a:lnL w="12700" cap="flat" cmpd="sng" algn="ctr">
+                      <a:solidFill>
+                        <a:srgbClr val="E9ECEF"/>
+                      </a:solidFill>
+                      <a:prstDash val="solid"/>
+                      <a:round/>
+                      <a:headEnd type="none" w="med" len="med"/>
+                      <a:tailEnd type="none" w="med" len="med"/>
+                    </a:lnL>
+                    <a:lnR w="12700" cap="flat" cmpd="sng" algn="ctr">
+                      <a:solidFill>
+                        <a:srgbClr val="E9ECEF"/>
+                      </a:solidFill>
+                      <a:prstDash val="solid"/>
+                      <a:round/>
+                      <a:headEnd type="none" w="med" len="med"/>
+                      <a:tailEnd type="none" w="med" len="med"/>
+                    </a:lnR>
+                    <a:lnT w="12700" cap="flat" cmpd="sng" algn="ctr">
+                      <a:solidFill>
+                        <a:srgbClr val="E9ECEF"/>
+                      </a:solidFill>
+                      <a:prstDash val="solid"/>
+                      <a:round/>
+                      <a:headEnd type="none" w="med" len="med"/>
+                      <a:tailEnd type="none" w="med" len="med"/>
+                    </a:lnT>
+                    <a:lnB w="12700" cap="flat" cmpd="sng" algn="ctr">
+                      <a:solidFill>
+                        <a:srgbClr val="E9ECEF"/>
+                      </a:solidFill>
+                      <a:prstDash val="solid"/>
+                      <a:round/>
+                      <a:headEnd type="none" w="med" len="med"/>
+                      <a:tailEnd type="none" w="med" len="med"/>
+                    </a:lnB>
+                  </a:tcPr>
+                </a:tc>
+                <a:tc>
+                  <a:txBody>
+                    <a:bodyPr/>
+                    <a:lstStyle/>
+                    <a:p>
+                      <a:pPr indent="0" marL="0">
+                        <a:buNone/>
+                      </a:pPr>
+                      <a:r>
+                        <a:rPr lang="en-US" sz="1100" dirty="0">
+                          <a:solidFill>
+                            <a:srgbClr val="22303C"/>
+                          </a:solidFill>
+                          <a:latin typeface="Calibri" pitchFamily="34" charset="0"/>
+                          <a:ea typeface="Calibri" pitchFamily="34" charset="-122"/>
+                          <a:cs typeface="Calibri" pitchFamily="34" charset="-120"/>
+                        </a:rPr>
+                        <a:t>the JDK</a:t>
+                      </a:r>
+                      <a:endParaRPr lang="en-US" sz="1100" dirty="0">
+                        <a:latin typeface="Calibri" charset="0"/>
+                        <a:ea typeface="Calibri" charset="0"/>
+                        <a:cs typeface="Calibri" charset="0"/>
+                      </a:endParaRPr>
+                    </a:p>
+                  </a:txBody>
+                  <a:tcPr marL="54864" marR="54864" marT="54864" marB="54864" anchor="ctr">
+                    <a:lnL w="12700" cap="flat" cmpd="sng" algn="ctr">
+                      <a:solidFill>
+                        <a:srgbClr val="E9ECEF"/>
+                      </a:solidFill>
+                      <a:prstDash val="solid"/>
+                      <a:round/>
+                      <a:headEnd type="none" w="med" len="med"/>
+                      <a:tailEnd type="none" w="med" len="med"/>
+                    </a:lnL>
+                    <a:lnR w="12700" cap="flat" cmpd="sng" algn="ctr">
+                      <a:solidFill>
+                        <a:srgbClr val="E9ECEF"/>
+                      </a:solidFill>
+                      <a:prstDash val="solid"/>
+                      <a:round/>
+                      <a:headEnd type="none" w="med" len="med"/>
+                      <a:tailEnd type="none" w="med" len="med"/>
+                    </a:lnR>
+                    <a:lnT w="12700" cap="flat" cmpd="sng" algn="ctr">
+                      <a:solidFill>
+                        <a:srgbClr val="E9ECEF"/>
+                      </a:solidFill>
+                      <a:prstDash val="solid"/>
+                      <a:round/>
+                      <a:headEnd type="none" w="med" len="med"/>
+                      <a:tailEnd type="none" w="med" len="med"/>
+                    </a:lnT>
+                    <a:lnB w="12700" cap="flat" cmpd="sng" algn="ctr">
+                      <a:solidFill>
+                        <a:srgbClr val="E9ECEF"/>
+                      </a:solidFill>
+                      <a:prstDash val="solid"/>
+                      <a:round/>
+                      <a:headEnd type="none" w="med" len="med"/>
+                      <a:tailEnd type="none" w="med" len="med"/>
+                    </a:lnB>
+                  </a:tcPr>
+                </a:tc>
+                <a:tc>
+                  <a:txBody>
+                    <a:bodyPr/>
+                    <a:lstStyle/>
+                    <a:p>
+                      <a:pPr indent="0" marL="0">
+                        <a:buNone/>
+                      </a:pPr>
+                      <a:r>
+                        <a:rPr lang="en-US" sz="1100" dirty="0">
+                          <a:solidFill>
+                            <a:srgbClr val="22303C"/>
+                          </a:solidFill>
+                          <a:latin typeface="Calibri" pitchFamily="34" charset="0"/>
+                          <a:ea typeface="Calibri" pitchFamily="34" charset="-122"/>
+                          <a:cs typeface="Calibri" pitchFamily="34" charset="-120"/>
+                        </a:rPr>
+                        <a:t>bytecode generated at run time, with ASM</a:t>
+                      </a:r>
+                      <a:endParaRPr lang="en-US" sz="1100" dirty="0">
+                        <a:latin typeface="Calibri" charset="0"/>
+                        <a:ea typeface="Calibri" charset="0"/>
+                        <a:cs typeface="Calibri" charset="0"/>
+                      </a:endParaRPr>
+                    </a:p>
+                  </a:txBody>
+                  <a:tcPr marL="54864" marR="54864" marT="54864" marB="54864" anchor="ctr">
+                    <a:lnL w="12700" cap="flat" cmpd="sng" algn="ctr">
+                      <a:solidFill>
+                        <a:srgbClr val="E9ECEF"/>
+                      </a:solidFill>
+                      <a:prstDash val="solid"/>
+                      <a:round/>
+                      <a:headEnd type="none" w="med" len="med"/>
+                      <a:tailEnd type="none" w="med" len="med"/>
+                    </a:lnL>
+                    <a:lnR w="12700" cap="flat" cmpd="sng" algn="ctr">
+                      <a:solidFill>
+                        <a:srgbClr val="E9ECEF"/>
+                      </a:solidFill>
+                      <a:prstDash val="solid"/>
+                      <a:round/>
+                      <a:headEnd type="none" w="med" len="med"/>
+                      <a:tailEnd type="none" w="med" len="med"/>
+                    </a:lnR>
+                    <a:lnT w="12700" cap="flat" cmpd="sng" algn="ctr">
+                      <a:solidFill>
+                        <a:srgbClr val="E9ECEF"/>
+                      </a:solidFill>
+                      <a:prstDash val="solid"/>
+                      <a:round/>
+                      <a:headEnd type="none" w="med" len="med"/>
+                      <a:tailEnd type="none" w="med" len="med"/>
+                    </a:lnT>
+                    <a:lnB w="12700" cap="flat" cmpd="sng" algn="ctr">
+                      <a:solidFill>
+                        <a:srgbClr val="E9ECEF"/>
+                      </a:solidFill>
+                      <a:prstDash val="solid"/>
+                      <a:round/>
+                      <a:headEnd type="none" w="med" len="med"/>
+                      <a:tailEnd type="none" w="med" len="med"/>
+                    </a:lnB>
+                  </a:tcPr>
+                </a:tc>
+              </a:tr>
+              <a:tr h="310896">
+                <a:tc>
+                  <a:txBody>
+                    <a:bodyPr/>
+                    <a:lstStyle/>
+                    <a:p>
+                      <a:pPr indent="0" marL="0">
+                        <a:buNone/>
+                      </a:pPr>
+                      <a:r>
+                        <a:rPr lang="en-US" sz="1100" dirty="0">
+                          <a:solidFill>
+                            <a:srgbClr val="22303C"/>
+                          </a:solidFill>
+                          <a:latin typeface="Calibri" pitchFamily="34" charset="0"/>
+                          <a:ea typeface="Calibri" pitchFamily="34" charset="-122"/>
+                          <a:cs typeface="Calibri" pitchFamily="34" charset="-120"/>
+                        </a:rPr>
+                        <a:t>Self-invocation</a:t>
+                      </a:r>
+                      <a:endParaRPr lang="en-US" sz="1100" dirty="0">
+                        <a:latin typeface="Calibri" charset="0"/>
+                        <a:ea typeface="Calibri" charset="0"/>
+                        <a:cs typeface="Calibri" charset="0"/>
+                      </a:endParaRPr>
+                    </a:p>
+                  </a:txBody>
+                  <a:tcPr marL="54864" marR="54864" marT="54864" marB="54864" anchor="ctr">
+                    <a:lnL w="12700" cap="flat" cmpd="sng" algn="ctr">
+                      <a:solidFill>
+                        <a:srgbClr val="E9ECEF"/>
+                      </a:solidFill>
+                      <a:prstDash val="solid"/>
+                      <a:round/>
+                      <a:headEnd type="none" w="med" len="med"/>
+                      <a:tailEnd type="none" w="med" len="med"/>
+                    </a:lnL>
+                    <a:lnR w="12700" cap="flat" cmpd="sng" algn="ctr">
+                      <a:solidFill>
+                        <a:srgbClr val="E9ECEF"/>
+                      </a:solidFill>
+                      <a:prstDash val="solid"/>
+                      <a:round/>
+                      <a:headEnd type="none" w="med" len="med"/>
+                      <a:tailEnd type="none" w="med" len="med"/>
+                    </a:lnR>
+                    <a:lnT w="12700" cap="flat" cmpd="sng" algn="ctr">
+                      <a:solidFill>
+                        <a:srgbClr val="E9ECEF"/>
+                      </a:solidFill>
+                      <a:prstDash val="solid"/>
+                      <a:round/>
+                      <a:headEnd type="none" w="med" len="med"/>
+                      <a:tailEnd type="none" w="med" len="med"/>
+                    </a:lnT>
+                    <a:lnB w="12700" cap="flat" cmpd="sng" algn="ctr">
+                      <a:solidFill>
+                        <a:srgbClr val="E9ECEF"/>
+                      </a:solidFill>
+                      <a:prstDash val="solid"/>
+                      <a:round/>
+                      <a:headEnd type="none" w="med" len="med"/>
+                      <a:tailEnd type="none" w="med" len="med"/>
+                    </a:lnB>
+                  </a:tcPr>
+                </a:tc>
+                <a:tc>
+                  <a:txBody>
+                    <a:bodyPr/>
+                    <a:lstStyle/>
+                    <a:p>
+                      <a:pPr indent="0" marL="0">
+                        <a:buNone/>
+                      </a:pPr>
+                      <a:r>
+                        <a:rPr lang="en-US" sz="1100" dirty="0">
+                          <a:solidFill>
+                            <a:srgbClr val="22303C"/>
+                          </a:solidFill>
+                          <a:latin typeface="Calibri" pitchFamily="34" charset="0"/>
+                          <a:ea typeface="Calibri" pitchFamily="34" charset="-122"/>
+                          <a:cs typeface="Calibri" pitchFamily="34" charset="-120"/>
+                        </a:rPr>
+                        <a:t>bypassed</a:t>
+                      </a:r>
+                      <a:endParaRPr lang="en-US" sz="1100" dirty="0">
+                        <a:latin typeface="Calibri" charset="0"/>
+                        <a:ea typeface="Calibri" charset="0"/>
+                        <a:cs typeface="Calibri" charset="0"/>
+                      </a:endParaRPr>
+                    </a:p>
+                  </a:txBody>
+                  <a:tcPr marL="54864" marR="54864" marT="54864" marB="54864" anchor="ctr">
+                    <a:lnL w="12700" cap="flat" cmpd="sng" algn="ctr">
+                      <a:solidFill>
+                        <a:srgbClr val="E9ECEF"/>
+                      </a:solidFill>
+                      <a:prstDash val="solid"/>
+                      <a:round/>
+                      <a:headEnd type="none" w="med" len="med"/>
+                      <a:tailEnd type="none" w="med" len="med"/>
+                    </a:lnL>
+                    <a:lnR w="12700" cap="flat" cmpd="sng" algn="ctr">
+                      <a:solidFill>
+                        <a:srgbClr val="E9ECEF"/>
+                      </a:solidFill>
+                      <a:prstDash val="solid"/>
+                      <a:round/>
+                      <a:headEnd type="none" w="med" len="med"/>
+                      <a:tailEnd type="none" w="med" len="med"/>
+                    </a:lnR>
+                    <a:lnT w="12700" cap="flat" cmpd="sng" algn="ctr">
+                      <a:solidFill>
+                        <a:srgbClr val="E9ECEF"/>
+                      </a:solidFill>
+                      <a:prstDash val="solid"/>
+                      <a:round/>
+                      <a:headEnd type="none" w="med" len="med"/>
+                      <a:tailEnd type="none" w="med" len="med"/>
+                    </a:lnT>
+                    <a:lnB w="12700" cap="flat" cmpd="sng" algn="ctr">
+                      <a:solidFill>
+                        <a:srgbClr val="E9ECEF"/>
+                      </a:solidFill>
+                      <a:prstDash val="solid"/>
+                      <a:round/>
+                      <a:headEnd type="none" w="med" len="med"/>
+                      <a:tailEnd type="none" w="med" len="med"/>
+                    </a:lnB>
+                  </a:tcPr>
+                </a:tc>
+                <a:tc>
+                  <a:txBody>
+                    <a:bodyPr/>
+                    <a:lstStyle/>
+                    <a:p>
+                      <a:pPr indent="0" marL="0">
+                        <a:buNone/>
+                      </a:pPr>
+                      <a:r>
+                        <a:rPr lang="en-US" sz="1100" dirty="0">
+                          <a:solidFill>
+                            <a:srgbClr val="22303C"/>
+                          </a:solidFill>
+                          <a:latin typeface="Calibri" pitchFamily="34" charset="0"/>
+                          <a:ea typeface="Calibri" pitchFamily="34" charset="-122"/>
+                          <a:cs typeface="Calibri" pitchFamily="34" charset="-120"/>
+                        </a:rPr>
+                        <a:t>bypassed too — nothing changes</a:t>
+                      </a:r>
+                      <a:endParaRPr lang="en-US" sz="1100" dirty="0">
+                        <a:latin typeface="Calibri" charset="0"/>
+                        <a:ea typeface="Calibri" charset="0"/>
+                        <a:cs typeface="Calibri" charset="0"/>
+                      </a:endParaRPr>
+                    </a:p>
+                  </a:txBody>
+                  <a:tcPr marL="54864" marR="54864" marT="54864" marB="54864" anchor="ctr">
+                    <a:lnL w="12700" cap="flat" cmpd="sng" algn="ctr">
+                      <a:solidFill>
+                        <a:srgbClr val="E9ECEF"/>
+                      </a:solidFill>
+                      <a:prstDash val="solid"/>
+                      <a:round/>
+                      <a:headEnd type="none" w="med" len="med"/>
+                      <a:tailEnd type="none" w="med" len="med"/>
+                    </a:lnL>
+                    <a:lnR w="12700" cap="flat" cmpd="sng" algn="ctr">
+                      <a:solidFill>
+                        <a:srgbClr val="E9ECEF"/>
+                      </a:solidFill>
+                      <a:prstDash val="solid"/>
+                      <a:round/>
+                      <a:headEnd type="none" w="med" len="med"/>
+                      <a:tailEnd type="none" w="med" len="med"/>
+                    </a:lnR>
+                    <a:lnT w="12700" cap="flat" cmpd="sng" algn="ctr">
+                      <a:solidFill>
+                        <a:srgbClr val="E9ECEF"/>
+                      </a:solidFill>
+                      <a:prstDash val="solid"/>
+                      <a:round/>
+                      <a:headEnd type="none" w="med" len="med"/>
+                      <a:tailEnd type="none" w="med" len="med"/>
+                    </a:lnT>
+                    <a:lnB w="12700" cap="flat" cmpd="sng" algn="ctr">
+                      <a:solidFill>
+                        <a:srgbClr val="E9ECEF"/>
+                      </a:solidFill>
+                      <a:prstDash val="solid"/>
+                      <a:round/>
+                      <a:headEnd type="none" w="med" len="med"/>
+                      <a:tailEnd type="none" w="med" len="med"/>
+                    </a:lnB>
+                  </a:tcPr>
+                </a:tc>
+              </a:tr>
+            </a:tbl>
+          </a:graphicData>
+        </a:graphic>
+      </p:graphicFrame>
+      <p:sp>
+        <p:nvSpPr>
+          <p:cNvPr id="7" name="Shape 4"/>
+          <p:cNvSpPr/>
+          <p:nvPr/>
+        </p:nvSpPr>
+        <p:spPr>
+          <a:xfrm>
+            <a:off x="457200" y="4160520"/>
+            <a:ext cx="8229600" cy="594360"/>
+          </a:xfrm>
+          <a:prstGeom prst="roundRect">
+            <a:avLst>
+              <a:gd name="adj" fmla="val 12308"/>
+            </a:avLst>
+          </a:prstGeom>
+          <a:solidFill>
+            <a:srgbClr val="FFFFFF"/>
+          </a:solidFill>
+          <a:ln w="25400">
+            <a:solidFill>
+              <a:srgbClr val="2F9E44"/>
+            </a:solidFill>
+            <a:prstDash val="solid"/>
+          </a:ln>
+        </p:spPr>
+      </p:sp>
+      <p:sp>
+        <p:nvSpPr>
+          <p:cNvPr id="8" name="Text 5"/>
+          <p:cNvSpPr txBox="1"/>
+          <p:nvPr/>
+        </p:nvSpPr>
+        <p:spPr>
+          <a:xfrm>
+            <a:off x="640080" y="4160520"/>
+            <a:ext cx="7863840" cy="594360"/>
+          </a:xfrm>
+          <a:prstGeom prst="rect">
+            <a:avLst/>
+          </a:prstGeom>
+          <a:noFill/>
+          <a:ln/>
+        </p:spPr>
+        <p:txBody>
+          <a:bodyPr wrap="square" lIns="0" tIns="0" rIns="0" bIns="0" rtlCol="0" anchor="ctr"/>
+          <a:lstStyle/>
+          <a:p>
+            <a:pPr indent="0" marL="0">
+              <a:buNone/>
+            </a:pPr>
+            <a:r>
+              <a:rPr lang="en-US" sz="1500" b="1" dirty="0">
+                <a:solidFill>
+                  <a:srgbClr val="2F9E44"/>
+                </a:solidFill>
+                <a:latin typeface="Calibri" pitchFamily="34" charset="0"/>
+                <a:ea typeface="Calibri" pitchFamily="34" charset="-122"/>
+                <a:cs typeface="Calibri" pitchFamily="34" charset="-120"/>
+              </a:rPr>
+              <a:t>It also rewrites @Configuration classes, so one @Bean method calling another returns the singleton. That is the one thing minispring cannot do.</a:t>
+            </a:r>
+            <a:endParaRPr lang="en-US" sz="1500" dirty="0"/>
+          </a:p>
+        </p:txBody>
+      </p:sp>
+    </p:spTree>
+  </p:cSld>
+  <p:clrMapOvr>
+    <a:masterClrMapping/>
+  </p:clrMapOvr>
+</p:sld>
+</file>
+
+<file path=ppt/slides/slide3.xml><?xml version="1.0" encoding="utf-8"?>
+<p:sld xmlns:a="http://schemas.openxmlformats.org/drawingml/2006/main" xmlns:r="http://schemas.openxmlformats.org/officeDocument/2006/relationships" xmlns:p="http://schemas.openxmlformats.org/presentationml/2006/main">
+  <p:cSld name="Slide 3">
+    <p:bg>
+      <p:bgPr>
+        <a:solidFill>
+          <a:srgbClr val="FFFFFF"/>
+        </a:solidFill>
+      </p:bgPr>
+    </p:bg>
+    <p:spTree>
+      <p:nvGrpSpPr>
+        <p:cNvPr id="1" name=""/>
+        <p:cNvGrpSpPr/>
+        <p:nvPr/>
+      </p:nvGrpSpPr>
+      <p:grpSpPr>
+        <a:xfrm>
+          <a:off x="0" y="0"/>
+          <a:ext cx="0" cy="0"/>
+          <a:chOff x="0" y="0"/>
+          <a:chExt cx="0" cy="0"/>
+        </a:xfrm>
+      </p:grpSpPr>
+      <p:sp>
+        <p:nvSpPr>
+          <p:cNvPr id="2" name="Text 0"/>
+          <p:cNvSpPr txBox="1"/>
+          <p:nvPr/>
+        </p:nvSpPr>
+        <p:spPr>
+          <a:xfrm>
+            <a:off x="457200" y="292608"/>
+            <a:ext cx="8229600" cy="713232"/>
+          </a:xfrm>
+          <a:prstGeom prst="rect">
+            <a:avLst/>
+          </a:prstGeom>
+          <a:noFill/>
+          <a:ln/>
+        </p:spPr>
+        <p:txBody>
+          <a:bodyPr wrap="square" lIns="0" tIns="0" rIns="0" bIns="0" rtlCol="0" anchor="t"/>
+          <a:lstStyle/>
+          <a:p>
+            <a:pPr indent="0" marL="0">
+              <a:buNone/>
+            </a:pPr>
+            <a:r>
+              <a:rPr lang="en-US" sz="3000" b="1" dirty="0">
+                <a:solidFill>
+                  <a:srgbClr val="22303C"/>
+                </a:solidFill>
+                <a:latin typeface="Cambria" pitchFamily="34" charset="0"/>
+                <a:ea typeface="Cambria" pitchFamily="34" charset="-122"/>
+                <a:cs typeface="Cambria" pitchFamily="34" charset="-120"/>
+              </a:rPr>
+              <a:t>You have written this a thousand times</a:t>
+            </a:r>
+            <a:endParaRPr lang="en-US" sz="3000" dirty="0"/>
+          </a:p>
+        </p:txBody>
+      </p:sp>
+      <p:sp>
+        <p:nvSpPr>
+          <p:cNvPr id="3" name="Shape 1"/>
+          <p:cNvSpPr/>
+          <p:nvPr/>
+        </p:nvSpPr>
+        <p:spPr>
+          <a:xfrm>
+            <a:off x="457200" y="1371600"/>
+            <a:ext cx="4754880" cy="2011680"/>
+          </a:xfrm>
+          <a:prstGeom prst="roundRect">
+            <a:avLst>
+              <a:gd name="adj" fmla="val 2727"/>
+            </a:avLst>
+          </a:prstGeom>
+          <a:solidFill>
+            <a:srgbClr val="F1F3F5"/>
+          </a:solidFill>
+          <a:ln w="12700">
+            <a:solidFill>
+              <a:srgbClr val="DEE2E6"/>
+            </a:solidFill>
+            <a:prstDash val="solid"/>
+          </a:ln>
+        </p:spPr>
+      </p:sp>
+      <p:sp>
+        <p:nvSpPr>
+          <p:cNvPr id="4" name="Text 2"/>
+          <p:cNvSpPr txBox="1"/>
+          <p:nvPr/>
+        </p:nvSpPr>
+        <p:spPr>
+          <a:xfrm>
+            <a:off x="621792" y="1481328"/>
+            <a:ext cx="4425696" cy="1792224"/>
+          </a:xfrm>
+          <a:prstGeom prst="rect">
+            <a:avLst/>
+          </a:prstGeom>
+          <a:noFill/>
+          <a:ln/>
+        </p:spPr>
+        <p:txBody>
+          <a:bodyPr wrap="square" lIns="0" tIns="0" rIns="0" bIns="0" rtlCol="0" anchor="ctr"/>
+          <a:lstStyle/>
+          <a:p>
+            <a:pPr indent="0" marL="0">
+              <a:lnSpc>
+                <a:spcPct val="115000"/>
+              </a:lnSpc>
+              <a:buNone/>
+            </a:pPr>
+            <a:r>
+              <a:rPr lang="en-US" sz="1500" dirty="0">
+                <a:solidFill>
+                  <a:srgbClr val="22303C"/>
+                </a:solidFill>
+                <a:latin typeface="Courier New" pitchFamily="34" charset="0"/>
+                <a:ea typeface="Courier New" pitchFamily="34" charset="-122"/>
+                <a:cs typeface="Courier New" pitchFamily="34" charset="-120"/>
+              </a:rPr>
+              <a:t>@Service</a:t>
+            </a:r>
+            <a:endParaRPr lang="en-US" sz="1500" dirty="0"/>
+          </a:p>
+          <a:p>
+            <a:pPr indent="0" marL="0">
+              <a:lnSpc>
+                <a:spcPct val="115000"/>
+              </a:lnSpc>
+              <a:buNone/>
+            </a:pPr>
+            <a:r>
+              <a:rPr lang="en-US" sz="1500" dirty="0">
+                <a:solidFill>
+                  <a:srgbClr val="22303C"/>
+                </a:solidFill>
+                <a:latin typeface="Courier New" pitchFamily="34" charset="0"/>
+                <a:ea typeface="Courier New" pitchFamily="34" charset="-122"/>
+                <a:cs typeface="Courier New" pitchFamily="34" charset="-120"/>
+              </a:rPr>
+              <a:t>public class OrderService {</a:t>
+            </a:r>
+            <a:endParaRPr lang="en-US" sz="1500" dirty="0"/>
+          </a:p>
+          <a:p>
+            <a:pPr indent="0" marL="0">
+              <a:lnSpc>
+                <a:spcPct val="115000"/>
+              </a:lnSpc>
+              <a:buNone/>
+            </a:pPr>
+            <a:endParaRPr lang="en-US" sz="1500" dirty="0"/>
+          </a:p>
+          <a:p>
+            <a:pPr indent="0" marL="0">
+              <a:lnSpc>
+                <a:spcPct val="115000"/>
+              </a:lnSpc>
+              <a:buNone/>
+            </a:pPr>
+            <a:r>
+              <a:rPr lang="en-US" sz="1500" dirty="0">
+                <a:solidFill>
+                  <a:srgbClr val="22303C"/>
+                </a:solidFill>
+                <a:latin typeface="Courier New" pitchFamily="34" charset="0"/>
+                <a:ea typeface="Courier New" pitchFamily="34" charset="-122"/>
+                <a:cs typeface="Courier New" pitchFamily="34" charset="-120"/>
+              </a:rPr>
+              <a:t>    @Autowired</a:t>
+            </a:r>
+            <a:endParaRPr lang="en-US" sz="1500" dirty="0"/>
+          </a:p>
+          <a:p>
+            <a:pPr indent="0" marL="0">
+              <a:lnSpc>
+                <a:spcPct val="115000"/>
+              </a:lnSpc>
+              <a:buNone/>
+            </a:pPr>
+            <a:r>
+              <a:rPr lang="en-US" sz="1500" dirty="0">
+                <a:solidFill>
+                  <a:srgbClr val="22303C"/>
+                </a:solidFill>
+                <a:latin typeface="Courier New" pitchFamily="34" charset="0"/>
+                <a:ea typeface="Courier New" pitchFamily="34" charset="-122"/>
+                <a:cs typeface="Courier New" pitchFamily="34" charset="-120"/>
+              </a:rPr>
+              <a:t>    private OrderRepository repository;</a:t>
+            </a:r>
+            <a:endParaRPr lang="en-US" sz="1500" dirty="0"/>
+          </a:p>
+          <a:p>
+            <a:pPr indent="0" marL="0">
+              <a:lnSpc>
+                <a:spcPct val="115000"/>
+              </a:lnSpc>
+              <a:buNone/>
+            </a:pPr>
+            <a:r>
+              <a:rPr lang="en-US" sz="1500" dirty="0">
+                <a:solidFill>
+                  <a:srgbClr val="22303C"/>
+                </a:solidFill>
+                <a:latin typeface="Courier New" pitchFamily="34" charset="0"/>
+                <a:ea typeface="Courier New" pitchFamily="34" charset="-122"/>
+                <a:cs typeface="Courier New" pitchFamily="34" charset="-120"/>
+              </a:rPr>
+              <a:t>}</a:t>
+            </a:r>
+            <a:endParaRPr lang="en-US" sz="1500" dirty="0"/>
+          </a:p>
+        </p:txBody>
+      </p:sp>
+      <p:sp>
+        <p:nvSpPr>
+          <p:cNvPr id="5" name="Text 3"/>
+          <p:cNvSpPr txBox="1"/>
+          <p:nvPr/>
+        </p:nvSpPr>
+        <p:spPr>
+          <a:xfrm>
+            <a:off x="5486400" y="1554480"/>
+            <a:ext cx="3291840" cy="457200"/>
+          </a:xfrm>
+          <a:prstGeom prst="rect">
+            <a:avLst/>
+          </a:prstGeom>
+          <a:noFill/>
+          <a:ln/>
+        </p:spPr>
+        <p:txBody>
+          <a:bodyPr wrap="square" lIns="0" tIns="0" rIns="0" bIns="0" rtlCol="0" anchor="ctr"/>
+          <a:lstStyle/>
+          <a:p>
+            <a:pPr indent="0" marL="0">
+              <a:buNone/>
+            </a:pPr>
+            <a:r>
+              <a:rPr lang="en-US" sz="2200" b="1" dirty="0">
+                <a:solidFill>
+                  <a:srgbClr val="22303C"/>
+                </a:solidFill>
+                <a:latin typeface="Cambria" pitchFamily="34" charset="0"/>
+                <a:ea typeface="Cambria" pitchFamily="34" charset="-122"/>
+                <a:cs typeface="Cambria" pitchFamily="34" charset="-120"/>
+              </a:rPr>
+              <a:t>Who creates this object?</a:t>
+            </a:r>
+            <a:endParaRPr lang="en-US" sz="2200" dirty="0"/>
+          </a:p>
+        </p:txBody>
+      </p:sp>
+      <p:sp>
+        <p:nvSpPr>
+          <p:cNvPr id="6" name="Text 4"/>
+          <p:cNvSpPr txBox="1"/>
+          <p:nvPr/>
+        </p:nvSpPr>
+        <p:spPr>
+          <a:xfrm>
+            <a:off x="5486400" y="2057400"/>
+            <a:ext cx="3291840" cy="731520"/>
+          </a:xfrm>
+          <a:prstGeom prst="rect">
+            <a:avLst/>
+          </a:prstGeom>
+          <a:noFill/>
+          <a:ln/>
+        </p:spPr>
+        <p:txBody>
+          <a:bodyPr wrap="square" lIns="0" tIns="0" rIns="0" bIns="0" rtlCol="0" anchor="ctr"/>
+          <a:lstStyle/>
+          <a:p>
+            <a:pPr indent="0" marL="0">
+              <a:buNone/>
+            </a:pPr>
+            <a:r>
+              <a:rPr lang="en-US" sz="1600" dirty="0">
+                <a:solidFill>
+                  <a:srgbClr val="5B6B7A"/>
+                </a:solidFill>
+                <a:latin typeface="Calibri" pitchFamily="34" charset="0"/>
+                <a:ea typeface="Calibri" pitchFamily="34" charset="-122"/>
+                <a:cs typeface="Calibri" pitchFamily="34" charset="-120"/>
+              </a:rPr>
+              <a:t>And how does it know what to put inside?</a:t>
+            </a:r>
+            <a:endParaRPr lang="en-US" sz="1600" dirty="0"/>
+          </a:p>
+        </p:txBody>
+      </p:sp>
+      <p:sp>
+        <p:nvSpPr>
+          <p:cNvPr id="7" name="Shape 5"/>
+          <p:cNvSpPr/>
+          <p:nvPr/>
+        </p:nvSpPr>
+        <p:spPr>
+          <a:xfrm>
+            <a:off x="457200" y="3931920"/>
+            <a:ext cx="8229600" cy="594360"/>
+          </a:xfrm>
+          <a:prstGeom prst="roundRect">
+            <a:avLst>
+              <a:gd name="adj" fmla="val 12308"/>
+            </a:avLst>
+          </a:prstGeom>
+          <a:solidFill>
+            <a:srgbClr val="FFFFFF"/>
+          </a:solidFill>
+          <a:ln w="25400">
+            <a:solidFill>
+              <a:srgbClr val="2F9E44"/>
+            </a:solidFill>
+            <a:prstDash val="solid"/>
+          </a:ln>
+        </p:spPr>
+      </p:sp>
+      <p:sp>
+        <p:nvSpPr>
+          <p:cNvPr id="8" name="Text 6"/>
+          <p:cNvSpPr txBox="1"/>
+          <p:nvPr/>
+        </p:nvSpPr>
+        <p:spPr>
+          <a:xfrm>
+            <a:off x="640080" y="3931920"/>
+            <a:ext cx="7863840" cy="594360"/>
+          </a:xfrm>
+          <a:prstGeom prst="rect">
+            <a:avLst/>
+          </a:prstGeom>
+          <a:noFill/>
+          <a:ln/>
+        </p:spPr>
+        <p:txBody>
+          <a:bodyPr wrap="square" lIns="0" tIns="0" rIns="0" bIns="0" rtlCol="0" anchor="ctr"/>
+          <a:lstStyle/>
+          <a:p>
+            <a:pPr indent="0" marL="0">
+              <a:buNone/>
+            </a:pPr>
+            <a:r>
+              <a:rPr lang="en-US" sz="1500" b="1" dirty="0">
+                <a:solidFill>
+                  <a:srgbClr val="2F9E44"/>
+                </a:solidFill>
+                <a:latin typeface="Calibri" pitchFamily="34" charset="0"/>
+                <a:ea typeface="Calibri" pitchFamily="34" charset="-122"/>
+                <a:cs typeface="Calibri" pitchFamily="34" charset="-120"/>
+              </a:rPr>
+              <a:t>Today we read the answer, line by line. It is not magic, it is about 1,200 lines.</a:t>
+            </a:r>
+            <a:endParaRPr lang="en-US" sz="1500" dirty="0"/>
+          </a:p>
+        </p:txBody>
+      </p:sp>
+    </p:spTree>
+  </p:cSld>
+  <p:clrMapOvr>
+    <a:masterClrMapping/>
+  </p:clrMapOvr>
+</p:sld>
+</file>
+
+<file path=ppt/slides/slide30.xml><?xml version="1.0" encoding="utf-8"?>
+<p:sld xmlns:a="http://schemas.openxmlformats.org/drawingml/2006/main" xmlns:r="http://schemas.openxmlformats.org/officeDocument/2006/relationships" xmlns:p="http://schemas.openxmlformats.org/presentationml/2006/main">
+  <p:cSld name="Slide 30">
+    <p:bg>
+      <p:bgPr>
+        <a:solidFill>
+          <a:srgbClr val="FFFFFF"/>
+        </a:solidFill>
+      </p:bgPr>
+    </p:bg>
+    <p:spTree>
+      <p:nvGrpSpPr>
+        <p:cNvPr id="1" name=""/>
+        <p:cNvGrpSpPr/>
+        <p:nvPr/>
+      </p:nvGrpSpPr>
+      <p:grpSpPr>
+        <a:xfrm>
+          <a:off x="0" y="0"/>
+          <a:ext cx="0" cy="0"/>
+          <a:chOff x="0" y="0"/>
+          <a:chExt cx="0" cy="0"/>
+        </a:xfrm>
+      </p:grpSpPr>
       <p:pic>
         <p:nvPicPr>
           <p:cNvPr id="2" name="Image 0" descr="C:\Users\ayoub\AppData\Local\Temp\claude\C--Users-ayoub-Desktop-spring-app\fce785a8-6c80-4616-ac90-1d6e8a1fc6e3\scratchpad\diagrams\d1-lifecycle.png">    </p:cNvPr>
@@ -19143,9 +21065,178 @@
 </p:sld>
 </file>
 
-<file path=ppt/slides/slide3.xml><?xml version="1.0" encoding="utf-8"?>
+<file path=ppt/slides/slide31.xml><?xml version="1.0" encoding="utf-8"?>
 <p:sld xmlns:a="http://schemas.openxmlformats.org/drawingml/2006/main" xmlns:r="http://schemas.openxmlformats.org/officeDocument/2006/relationships" xmlns:p="http://schemas.openxmlformats.org/presentationml/2006/main">
-  <p:cSld name="Slide 3">
+  <p:cSld name="Slide 31">
+    <p:bg>
+      <p:bgPr>
+        <a:solidFill>
+          <a:srgbClr val="1B2430"/>
+        </a:solidFill>
+      </p:bgPr>
+    </p:bg>
+    <p:spTree>
+      <p:nvGrpSpPr>
+        <p:cNvPr id="1" name=""/>
+        <p:cNvGrpSpPr/>
+        <p:nvPr/>
+      </p:nvGrpSpPr>
+      <p:grpSpPr>
+        <a:xfrm>
+          <a:off x="0" y="0"/>
+          <a:ext cx="0" cy="0"/>
+          <a:chOff x="0" y="0"/>
+          <a:chExt cx="0" cy="0"/>
+        </a:xfrm>
+      </p:grpSpPr>
+      <p:sp>
+        <p:nvSpPr>
+          <p:cNvPr id="2" name="Shape 0"/>
+          <p:cNvSpPr/>
+          <p:nvPr/>
+        </p:nvSpPr>
+        <p:spPr>
+          <a:xfrm>
+            <a:off x="822960" y="1920240"/>
+            <a:ext cx="1005840" cy="1005840"/>
+          </a:xfrm>
+          <a:prstGeom prst="ellipse">
+            <a:avLst/>
+          </a:prstGeom>
+          <a:solidFill>
+            <a:srgbClr val="2F9E44"/>
+          </a:solidFill>
+          <a:ln/>
+        </p:spPr>
+      </p:sp>
+      <p:sp>
+        <p:nvSpPr>
+          <p:cNvPr id="3" name="Text 1"/>
+          <p:cNvSpPr txBox="1"/>
+          <p:nvPr/>
+        </p:nvSpPr>
+        <p:spPr>
+          <a:xfrm>
+            <a:off x="822960" y="1920240"/>
+            <a:ext cx="1005840" cy="1005840"/>
+          </a:xfrm>
+          <a:prstGeom prst="rect">
+            <a:avLst/>
+          </a:prstGeom>
+          <a:noFill/>
+          <a:ln/>
+        </p:spPr>
+        <p:txBody>
+          <a:bodyPr wrap="square" lIns="0" tIns="0" rIns="0" bIns="0" rtlCol="0" anchor="ctr"/>
+          <a:lstStyle/>
+          <a:p>
+            <a:pPr algn="ctr" indent="0" marL="0">
+              <a:buNone/>
+            </a:pPr>
+            <a:r>
+              <a:rPr lang="en-US" sz="4000" b="1" dirty="0">
+                <a:solidFill>
+                  <a:srgbClr val="FFFFFF"/>
+                </a:solidFill>
+                <a:latin typeface="Cambria" pitchFamily="34" charset="0"/>
+                <a:ea typeface="Cambria" pitchFamily="34" charset="-122"/>
+                <a:cs typeface="Cambria" pitchFamily="34" charset="-120"/>
+              </a:rPr>
+              <a:t>5</a:t>
+            </a:r>
+            <a:endParaRPr lang="en-US" sz="4000" dirty="0"/>
+          </a:p>
+        </p:txBody>
+      </p:sp>
+      <p:sp>
+        <p:nvSpPr>
+          <p:cNvPr id="4" name="Text 2"/>
+          <p:cNvSpPr txBox="1"/>
+          <p:nvPr/>
+        </p:nvSpPr>
+        <p:spPr>
+          <a:xfrm>
+            <a:off x="2103120" y="1965960"/>
+            <a:ext cx="6400800" cy="640080"/>
+          </a:xfrm>
+          <a:prstGeom prst="rect">
+            <a:avLst/>
+          </a:prstGeom>
+          <a:noFill/>
+          <a:ln/>
+        </p:spPr>
+        <p:txBody>
+          <a:bodyPr wrap="square" lIns="0" tIns="0" rIns="0" bIns="0" rtlCol="0" anchor="ctr"/>
+          <a:lstStyle/>
+          <a:p>
+            <a:pPr indent="0" marL="0">
+              <a:buNone/>
+            </a:pPr>
+            <a:r>
+              <a:rPr lang="en-US" sz="3000" b="1" dirty="0">
+                <a:solidFill>
+                  <a:srgbClr val="FFFFFF"/>
+                </a:solidFill>
+                <a:latin typeface="Cambria" pitchFamily="34" charset="0"/>
+                <a:ea typeface="Cambria" pitchFamily="34" charset="-122"/>
+                <a:cs typeface="Cambria" pitchFamily="34" charset="-120"/>
+              </a:rPr>
+              <a:t>Invent your own annotation</a:t>
+            </a:r>
+            <a:endParaRPr lang="en-US" sz="3000" dirty="0"/>
+          </a:p>
+        </p:txBody>
+      </p:sp>
+      <p:sp>
+        <p:nvSpPr>
+          <p:cNvPr id="5" name="Text 3"/>
+          <p:cNvSpPr txBox="1"/>
+          <p:nvPr/>
+        </p:nvSpPr>
+        <p:spPr>
+          <a:xfrm>
+            <a:off x="2103120" y="2606040"/>
+            <a:ext cx="6400800" cy="457200"/>
+          </a:xfrm>
+          <a:prstGeom prst="rect">
+            <a:avLst/>
+          </a:prstGeom>
+          <a:noFill/>
+          <a:ln/>
+        </p:spPr>
+        <p:txBody>
+          <a:bodyPr wrap="square" lIns="0" tIns="0" rIns="0" bIns="0" rtlCol="0" anchor="ctr"/>
+          <a:lstStyle/>
+          <a:p>
+            <a:pPr indent="0" marL="0">
+              <a:buNone/>
+            </a:pPr>
+            <a:r>
+              <a:rPr lang="en-US" sz="1600" dirty="0">
+                <a:solidFill>
+                  <a:srgbClr val="C7D2DD"/>
+                </a:solidFill>
+                <a:latin typeface="Calibri" pitchFamily="34" charset="0"/>
+                <a:ea typeface="Calibri" pitchFamily="34" charset="-122"/>
+                <a:cs typeface="Calibri" pitchFamily="34" charset="-120"/>
+              </a:rPr>
+              <a:t>The moment this stops being someone else's framework</a:t>
+            </a:r>
+            <a:endParaRPr lang="en-US" sz="1600" dirty="0"/>
+          </a:p>
+        </p:txBody>
+      </p:sp>
+    </p:spTree>
+  </p:cSld>
+  <p:clrMapOvr>
+    <a:masterClrMapping/>
+  </p:clrMapOvr>
+</p:sld>
+</file>
+
+<file path=ppt/slides/slide32.xml><?xml version="1.0" encoding="utf-8"?>
+<p:sld xmlns:a="http://schemas.openxmlformats.org/drawingml/2006/main" xmlns:r="http://schemas.openxmlformats.org/officeDocument/2006/relationships" xmlns:p="http://schemas.openxmlformats.org/presentationml/2006/main">
+  <p:cSld name="Slide 32">
     <p:bg>
       <p:bgPr>
         <a:solidFill>
@@ -19200,7 +21291,7 @@
                 <a:ea typeface="Cambria" pitchFamily="34" charset="-122"/>
                 <a:cs typeface="Cambria" pitchFamily="34" charset="-120"/>
               </a:rPr>
-              <a:t>You have written this a thousand times</a:t>
+              <a:t>@Timed, in three steps</a:t>
             </a:r>
             <a:endParaRPr lang="en-US" sz="3000" dirty="0"/>
           </a:p>
@@ -19208,18 +21299,57 @@
       </p:sp>
       <p:sp>
         <p:nvSpPr>
-          <p:cNvPr id="3" name="Shape 1"/>
+          <p:cNvPr id="3" name="Text 1"/>
+          <p:cNvSpPr txBox="1"/>
+          <p:nvPr/>
+        </p:nvSpPr>
+        <p:spPr>
+          <a:xfrm>
+            <a:off x="457200" y="987552"/>
+            <a:ext cx="8229600" cy="292608"/>
+          </a:xfrm>
+          <a:prstGeom prst="rect">
+            <a:avLst/>
+          </a:prstGeom>
+          <a:noFill/>
+          <a:ln/>
+        </p:spPr>
+        <p:txBody>
+          <a:bodyPr wrap="square" lIns="0" tIns="0" rIns="0" bIns="0" rtlCol="0" anchor="ctr"/>
+          <a:lstStyle/>
+          <a:p>
+            <a:pPr indent="0" marL="0">
+              <a:buNone/>
+            </a:pPr>
+            <a:r>
+              <a:rPr lang="en-US" sz="1500" dirty="0">
+                <a:solidFill>
+                  <a:srgbClr val="5B6B7A"/>
+                </a:solidFill>
+                <a:latin typeface="Calibri" pitchFamily="34" charset="0"/>
+                <a:ea typeface="Calibri" pitchFamily="34" charset="-122"/>
+                <a:cs typeface="Calibri" pitchFamily="34" charset="-120"/>
+              </a:rPr>
+              <a:t>The same pattern as @Transactional</a:t>
+            </a:r>
+            <a:endParaRPr lang="en-US" sz="1500" dirty="0"/>
+          </a:p>
+        </p:txBody>
+      </p:sp>
+      <p:sp>
+        <p:nvSpPr>
+          <p:cNvPr id="4" name="Shape 2"/>
           <p:cNvSpPr/>
           <p:nvPr/>
         </p:nvSpPr>
         <p:spPr>
           <a:xfrm>
-            <a:off x="457200" y="1371600"/>
-            <a:ext cx="4754880" cy="2011680"/>
+            <a:off x="457200" y="1325880"/>
+            <a:ext cx="8229600" cy="685800"/>
           </a:xfrm>
           <a:prstGeom prst="roundRect">
             <a:avLst>
-              <a:gd name="adj" fmla="val 2727"/>
+              <a:gd name="adj" fmla="val 8000"/>
             </a:avLst>
           </a:prstGeom>
           <a:solidFill>
@@ -19235,14 +21365,14 @@
       </p:sp>
       <p:sp>
         <p:nvSpPr>
-          <p:cNvPr id="4" name="Text 2"/>
+          <p:cNvPr id="5" name="Text 3"/>
           <p:cNvSpPr txBox="1"/>
           <p:nvPr/>
         </p:nvSpPr>
         <p:spPr>
           <a:xfrm>
-            <a:off x="621792" y="1481328"/>
-            <a:ext cx="4425696" cy="1792224"/>
+            <a:off x="621792" y="1435608"/>
+            <a:ext cx="7900416" cy="466344"/>
           </a:xfrm>
           <a:prstGeom prst="rect">
             <a:avLst/>
@@ -19261,7 +21391,7 @@
               <a:buNone/>
             </a:pPr>
             <a:r>
-              <a:rPr lang="en-US" sz="1500" dirty="0">
+              <a:rPr lang="en-US" sz="1200" dirty="0">
                 <a:solidFill>
                   <a:srgbClr val="22303C"/>
                 </a:solidFill>
@@ -19269,9 +21399,9 @@
                 <a:ea typeface="Courier New" pitchFamily="34" charset="-122"/>
                 <a:cs typeface="Courier New" pitchFamily="34" charset="-120"/>
               </a:rPr>
-              <a:t>@Service</a:t>
-            </a:r>
-            <a:endParaRPr lang="en-US" sz="1500" dirty="0"/>
+              <a:t>@Retention(RUNTIME) @Target(METHOD)</a:t>
+            </a:r>
+            <a:endParaRPr lang="en-US" sz="1200" dirty="0"/>
           </a:p>
           <a:p>
             <a:pPr indent="0" marL="0">
@@ -19281,7 +21411,7 @@
               <a:buNone/>
             </a:pPr>
             <a:r>
-              <a:rPr lang="en-US" sz="1500" dirty="0">
+              <a:rPr lang="en-US" sz="1200" dirty="0">
                 <a:solidFill>
                   <a:srgbClr val="22303C"/>
                 </a:solidFill>
@@ -19289,91 +21419,22 @@
                 <a:ea typeface="Courier New" pitchFamily="34" charset="-122"/>
                 <a:cs typeface="Courier New" pitchFamily="34" charset="-120"/>
               </a:rPr>
-              <a:t>public class OrderService {</a:t>
-            </a:r>
-            <a:endParaRPr lang="en-US" sz="1500" dirty="0"/>
-          </a:p>
-          <a:p>
-            <a:pPr indent="0" marL="0">
-              <a:lnSpc>
-                <a:spcPct val="115000"/>
-              </a:lnSpc>
-              <a:buNone/>
-            </a:pPr>
-            <a:endParaRPr lang="en-US" sz="1500" dirty="0"/>
-          </a:p>
-          <a:p>
-            <a:pPr indent="0" marL="0">
-              <a:lnSpc>
-                <a:spcPct val="115000"/>
-              </a:lnSpc>
-              <a:buNone/>
-            </a:pPr>
-            <a:r>
-              <a:rPr lang="en-US" sz="1500" dirty="0">
-                <a:solidFill>
-                  <a:srgbClr val="22303C"/>
-                </a:solidFill>
-                <a:latin typeface="Courier New" pitchFamily="34" charset="0"/>
-                <a:ea typeface="Courier New" pitchFamily="34" charset="-122"/>
-                <a:cs typeface="Courier New" pitchFamily="34" charset="-120"/>
-              </a:rPr>
-              <a:t>    @Autowired</a:t>
-            </a:r>
-            <a:endParaRPr lang="en-US" sz="1500" dirty="0"/>
-          </a:p>
-          <a:p>
-            <a:pPr indent="0" marL="0">
-              <a:lnSpc>
-                <a:spcPct val="115000"/>
-              </a:lnSpc>
-              <a:buNone/>
-            </a:pPr>
-            <a:r>
-              <a:rPr lang="en-US" sz="1500" dirty="0">
-                <a:solidFill>
-                  <a:srgbClr val="22303C"/>
-                </a:solidFill>
-                <a:latin typeface="Courier New" pitchFamily="34" charset="0"/>
-                <a:ea typeface="Courier New" pitchFamily="34" charset="-122"/>
-                <a:cs typeface="Courier New" pitchFamily="34" charset="-120"/>
-              </a:rPr>
-              <a:t>    private OrderRepository repository;</a:t>
-            </a:r>
-            <a:endParaRPr lang="en-US" sz="1500" dirty="0"/>
-          </a:p>
-          <a:p>
-            <a:pPr indent="0" marL="0">
-              <a:lnSpc>
-                <a:spcPct val="115000"/>
-              </a:lnSpc>
-              <a:buNone/>
-            </a:pPr>
-            <a:r>
-              <a:rPr lang="en-US" sz="1500" dirty="0">
-                <a:solidFill>
-                  <a:srgbClr val="22303C"/>
-                </a:solidFill>
-                <a:latin typeface="Courier New" pitchFamily="34" charset="0"/>
-                <a:ea typeface="Courier New" pitchFamily="34" charset="-122"/>
-                <a:cs typeface="Courier New" pitchFamily="34" charset="-120"/>
-              </a:rPr>
-              <a:t>}</a:t>
-            </a:r>
-            <a:endParaRPr lang="en-US" sz="1500" dirty="0"/>
+              <a:t>public @interface Timed { }</a:t>
+            </a:r>
+            <a:endParaRPr lang="en-US" sz="1200" dirty="0"/>
           </a:p>
         </p:txBody>
       </p:sp>
       <p:sp>
         <p:nvSpPr>
-          <p:cNvPr id="5" name="Text 3"/>
+          <p:cNvPr id="6" name="Text 4"/>
           <p:cNvSpPr txBox="1"/>
           <p:nvPr/>
         </p:nvSpPr>
         <p:spPr>
           <a:xfrm>
-            <a:off x="5486400" y="1554480"/>
-            <a:ext cx="3291840" cy="457200"/>
+            <a:off x="457200" y="2057400"/>
+            <a:ext cx="3657600" cy="256032"/>
           </a:xfrm>
           <a:prstGeom prst="rect">
             <a:avLst/>
@@ -19389,30 +21450,57 @@
               <a:buNone/>
             </a:pPr>
             <a:r>
-              <a:rPr lang="en-US" sz="2200" b="1" dirty="0">
+              <a:rPr lang="en-US" sz="1200" b="1" dirty="0">
                 <a:solidFill>
-                  <a:srgbClr val="22303C"/>
+                  <a:srgbClr val="2F9E44"/>
                 </a:solidFill>
-                <a:latin typeface="Cambria" pitchFamily="34" charset="0"/>
-                <a:ea typeface="Cambria" pitchFamily="34" charset="-122"/>
-                <a:cs typeface="Cambria" pitchFamily="34" charset="-120"/>
+                <a:latin typeface="Calibri" pitchFamily="34" charset="0"/>
+                <a:ea typeface="Calibri" pitchFamily="34" charset="-122"/>
+                <a:cs typeface="Calibri" pitchFamily="34" charset="-120"/>
               </a:rPr>
-              <a:t>Who creates this object?</a:t>
-            </a:r>
-            <a:endParaRPr lang="en-US" sz="2200" dirty="0"/>
+              <a:t>1. The sticker</a:t>
+            </a:r>
+            <a:endParaRPr lang="en-US" sz="1200" dirty="0"/>
           </a:p>
         </p:txBody>
       </p:sp>
       <p:sp>
         <p:nvSpPr>
-          <p:cNvPr id="6" name="Text 4"/>
+          <p:cNvPr id="7" name="Shape 5"/>
+          <p:cNvSpPr/>
+          <p:nvPr/>
+        </p:nvSpPr>
+        <p:spPr>
+          <a:xfrm>
+            <a:off x="457200" y="2377440"/>
+            <a:ext cx="8229600" cy="1097280"/>
+          </a:xfrm>
+          <a:prstGeom prst="roundRect">
+            <a:avLst>
+              <a:gd name="adj" fmla="val 5000"/>
+            </a:avLst>
+          </a:prstGeom>
+          <a:solidFill>
+            <a:srgbClr val="F1F3F5"/>
+          </a:solidFill>
+          <a:ln w="12700">
+            <a:solidFill>
+              <a:srgbClr val="DEE2E6"/>
+            </a:solidFill>
+            <a:prstDash val="solid"/>
+          </a:ln>
+        </p:spPr>
+      </p:sp>
+      <p:sp>
+        <p:nvSpPr>
+          <p:cNvPr id="8" name="Text 6"/>
           <p:cNvSpPr txBox="1"/>
           <p:nvPr/>
         </p:nvSpPr>
         <p:spPr>
           <a:xfrm>
-            <a:off x="5486400" y="2057400"/>
-            <a:ext cx="3291840" cy="731520"/>
+            <a:off x="621792" y="2487168"/>
+            <a:ext cx="7900416" cy="877824"/>
           </a:xfrm>
           <a:prstGeom prst="rect">
             <a:avLst/>
@@ -19425,26 +21513,128 @@
           <a:lstStyle/>
           <a:p>
             <a:pPr indent="0" marL="0">
+              <a:lnSpc>
+                <a:spcPct val="115000"/>
+              </a:lnSpc>
               <a:buNone/>
             </a:pPr>
             <a:r>
-              <a:rPr lang="en-US" sz="1600" dirty="0">
+              <a:rPr lang="en-US" sz="1200" dirty="0">
                 <a:solidFill>
-                  <a:srgbClr val="5B6B7A"/>
+                  <a:srgbClr val="22303C"/>
+                </a:solidFill>
+                <a:latin typeface="Courier New" pitchFamily="34" charset="0"/>
+                <a:ea typeface="Courier New" pitchFamily="34" charset="-122"/>
+                <a:cs typeface="Courier New" pitchFamily="34" charset="-120"/>
+              </a:rPr>
+              <a:t>public Object postProcessAfterInitialization(Object bean, String name) {</a:t>
+            </a:r>
+            <a:endParaRPr lang="en-US" sz="1200" dirty="0"/>
+          </a:p>
+          <a:p>
+            <a:pPr indent="0" marL="0">
+              <a:lnSpc>
+                <a:spcPct val="115000"/>
+              </a:lnSpc>
+              <a:buNone/>
+            </a:pPr>
+            <a:r>
+              <a:rPr lang="en-US" sz="1200" dirty="0">
+                <a:solidFill>
+                  <a:srgbClr val="22303C"/>
+                </a:solidFill>
+                <a:latin typeface="Courier New" pitchFamily="34" charset="0"/>
+                <a:ea typeface="Courier New" pitchFamily="34" charset="-122"/>
+                <a:cs typeface="Courier New" pitchFamily="34" charset="-120"/>
+              </a:rPr>
+              <a:t>    // if a method carries @Timed, return a proxy that measures the call</a:t>
+            </a:r>
+            <a:endParaRPr lang="en-US" sz="1200" dirty="0"/>
+          </a:p>
+          <a:p>
+            <a:pPr indent="0" marL="0">
+              <a:lnSpc>
+                <a:spcPct val="115000"/>
+              </a:lnSpc>
+              <a:buNone/>
+            </a:pPr>
+            <a:r>
+              <a:rPr lang="en-US" sz="1200" dirty="0">
+                <a:solidFill>
+                  <a:srgbClr val="22303C"/>
+                </a:solidFill>
+                <a:latin typeface="Courier New" pitchFamily="34" charset="0"/>
+                <a:ea typeface="Courier New" pitchFamily="34" charset="-122"/>
+                <a:cs typeface="Courier New" pitchFamily="34" charset="-120"/>
+              </a:rPr>
+              <a:t>    return Proxy.newProxyInstance(loader, interfaces, handler);</a:t>
+            </a:r>
+            <a:endParaRPr lang="en-US" sz="1200" dirty="0"/>
+          </a:p>
+          <a:p>
+            <a:pPr indent="0" marL="0">
+              <a:lnSpc>
+                <a:spcPct val="115000"/>
+              </a:lnSpc>
+              <a:buNone/>
+            </a:pPr>
+            <a:r>
+              <a:rPr lang="en-US" sz="1200" dirty="0">
+                <a:solidFill>
+                  <a:srgbClr val="22303C"/>
+                </a:solidFill>
+                <a:latin typeface="Courier New" pitchFamily="34" charset="0"/>
+                <a:ea typeface="Courier New" pitchFamily="34" charset="-122"/>
+                <a:cs typeface="Courier New" pitchFamily="34" charset="-120"/>
+              </a:rPr>
+              <a:t>}</a:t>
+            </a:r>
+            <a:endParaRPr lang="en-US" sz="1200" dirty="0"/>
+          </a:p>
+        </p:txBody>
+      </p:sp>
+      <p:sp>
+        <p:nvSpPr>
+          <p:cNvPr id="9" name="Text 7"/>
+          <p:cNvSpPr txBox="1"/>
+          <p:nvPr/>
+        </p:nvSpPr>
+        <p:spPr>
+          <a:xfrm>
+            <a:off x="457200" y="3520440"/>
+            <a:ext cx="8229600" cy="274320"/>
+          </a:xfrm>
+          <a:prstGeom prst="rect">
+            <a:avLst/>
+          </a:prstGeom>
+          <a:noFill/>
+          <a:ln/>
+        </p:spPr>
+        <p:txBody>
+          <a:bodyPr wrap="square" lIns="0" tIns="0" rIns="0" bIns="0" rtlCol="0" anchor="ctr"/>
+          <a:lstStyle/>
+          <a:p>
+            <a:pPr indent="0" marL="0">
+              <a:buNone/>
+            </a:pPr>
+            <a:r>
+              <a:rPr lang="en-US" sz="1200" b="1" dirty="0">
+                <a:solidFill>
+                  <a:srgbClr val="2F9E44"/>
                 </a:solidFill>
                 <a:latin typeface="Calibri" pitchFamily="34" charset="0"/>
                 <a:ea typeface="Calibri" pitchFamily="34" charset="-122"/>
                 <a:cs typeface="Calibri" pitchFamily="34" charset="-120"/>
               </a:rPr>
-              <a:t>And how does it know what to put inside?</a:t>
-            </a:r>
-            <a:endParaRPr lang="en-US" sz="1600" dirty="0"/>
+              <a:t>2. A BeanPostProcessor that wraps the bean   ·   3. A test that proves the duration is logged</a:t>
+            </a:r>
+            <a:endParaRPr lang="en-US" sz="1200" dirty="0"/>
           </a:p>
         </p:txBody>
       </p:sp>
       <p:sp>
         <p:nvSpPr>
-          <p:cNvPr id="7" name="Shape 5"/>
+          <p:cNvPr id="10" name="Shape 8"/>
           <p:cNvSpPr/>
           <p:nvPr/>
         </p:nvSpPr>
@@ -19471,7 +21661,7 @@
       </p:sp>
       <p:sp>
         <p:nvSpPr>
-          <p:cNvPr id="8" name="Text 6"/>
+          <p:cNvPr id="11" name="Text 9"/>
           <p:cNvSpPr txBox="1"/>
           <p:nvPr/>
         </p:nvSpPr>
@@ -19502,7 +21692,7 @@
                 <a:ea typeface="Calibri" pitchFamily="34" charset="-122"/>
                 <a:cs typeface="Calibri" pitchFamily="34" charset="-120"/>
               </a:rPr>
-              <a:t>Today we read the answer, line by line. It is not magic, it is about 1,200 lines.</a:t>
+              <a:t>Thirty lines. You have just written the mechanism behind @Cacheable, @Retry and @Async.</a:t>
             </a:r>
             <a:endParaRPr lang="en-US" sz="1500" dirty="0"/>
           </a:p>
@@ -19516,9 +21706,9 @@
 </p:sld>
 </file>
 
-<file path=ppt/slides/slide30.xml><?xml version="1.0" encoding="utf-8"?>
+<file path=ppt/slides/slide33.xml><?xml version="1.0" encoding="utf-8"?>
 <p:sld xmlns:a="http://schemas.openxmlformats.org/drawingml/2006/main" xmlns:r="http://schemas.openxmlformats.org/officeDocument/2006/relationships" xmlns:p="http://schemas.openxmlformats.org/presentationml/2006/main">
-  <p:cSld name="Slide 30">
+  <p:cSld name="Slide 33">
     <p:bg>
       <p:bgPr>
         <a:solidFill>
@@ -19593,7 +21783,7 @@
                 <a:ea typeface="Cambria" pitchFamily="34" charset="-122"/>
                 <a:cs typeface="Cambria" pitchFamily="34" charset="-120"/>
               </a:rPr>
-              <a:t>5</a:t>
+              <a:t>6</a:t>
             </a:r>
             <a:endParaRPr lang="en-US" sz="4000" dirty="0"/>
           </a:p>
@@ -19632,7 +21822,7 @@
                 <a:ea typeface="Cambria" pitchFamily="34" charset="-122"/>
                 <a:cs typeface="Cambria" pitchFamily="34" charset="-120"/>
               </a:rPr>
-              <a:t>Invent your own annotation</a:t>
+              <a:t>The Boot layer: auto-configuration</a:t>
             </a:r>
             <a:endParaRPr lang="en-US" sz="3000" dirty="0"/>
           </a:p>
@@ -19671,7 +21861,7 @@
                 <a:ea typeface="Calibri" pitchFamily="34" charset="-122"/>
                 <a:cs typeface="Calibri" pitchFamily="34" charset="-120"/>
               </a:rPr>
-              <a:t>The moment this stops being someone else's framework</a:t>
+              <a:t>How @Conditional decides what gets wired</a:t>
             </a:r>
             <a:endParaRPr lang="en-US" sz="1600" dirty="0"/>
           </a:p>
@@ -19685,650 +21875,9 @@
 </p:sld>
 </file>
 
-<file path=ppt/slides/slide31.xml><?xml version="1.0" encoding="utf-8"?>
+<file path=ppt/slides/slide34.xml><?xml version="1.0" encoding="utf-8"?>
 <p:sld xmlns:a="http://schemas.openxmlformats.org/drawingml/2006/main" xmlns:r="http://schemas.openxmlformats.org/officeDocument/2006/relationships" xmlns:p="http://schemas.openxmlformats.org/presentationml/2006/main">
-  <p:cSld name="Slide 31">
-    <p:bg>
-      <p:bgPr>
-        <a:solidFill>
-          <a:srgbClr val="FFFFFF"/>
-        </a:solidFill>
-      </p:bgPr>
-    </p:bg>
-    <p:spTree>
-      <p:nvGrpSpPr>
-        <p:cNvPr id="1" name=""/>
-        <p:cNvGrpSpPr/>
-        <p:nvPr/>
-      </p:nvGrpSpPr>
-      <p:grpSpPr>
-        <a:xfrm>
-          <a:off x="0" y="0"/>
-          <a:ext cx="0" cy="0"/>
-          <a:chOff x="0" y="0"/>
-          <a:chExt cx="0" cy="0"/>
-        </a:xfrm>
-      </p:grpSpPr>
-      <p:sp>
-        <p:nvSpPr>
-          <p:cNvPr id="2" name="Text 0"/>
-          <p:cNvSpPr txBox="1"/>
-          <p:nvPr/>
-        </p:nvSpPr>
-        <p:spPr>
-          <a:xfrm>
-            <a:off x="457200" y="292608"/>
-            <a:ext cx="8229600" cy="713232"/>
-          </a:xfrm>
-          <a:prstGeom prst="rect">
-            <a:avLst/>
-          </a:prstGeom>
-          <a:noFill/>
-          <a:ln/>
-        </p:spPr>
-        <p:txBody>
-          <a:bodyPr wrap="square" lIns="0" tIns="0" rIns="0" bIns="0" rtlCol="0" anchor="t"/>
-          <a:lstStyle/>
-          <a:p>
-            <a:pPr indent="0" marL="0">
-              <a:buNone/>
-            </a:pPr>
-            <a:r>
-              <a:rPr lang="en-US" sz="3000" b="1" dirty="0">
-                <a:solidFill>
-                  <a:srgbClr val="22303C"/>
-                </a:solidFill>
-                <a:latin typeface="Cambria" pitchFamily="34" charset="0"/>
-                <a:ea typeface="Cambria" pitchFamily="34" charset="-122"/>
-                <a:cs typeface="Cambria" pitchFamily="34" charset="-120"/>
-              </a:rPr>
-              <a:t>@Timed, in three steps</a:t>
-            </a:r>
-            <a:endParaRPr lang="en-US" sz="3000" dirty="0"/>
-          </a:p>
-        </p:txBody>
-      </p:sp>
-      <p:sp>
-        <p:nvSpPr>
-          <p:cNvPr id="3" name="Text 1"/>
-          <p:cNvSpPr txBox="1"/>
-          <p:nvPr/>
-        </p:nvSpPr>
-        <p:spPr>
-          <a:xfrm>
-            <a:off x="457200" y="987552"/>
-            <a:ext cx="8229600" cy="292608"/>
-          </a:xfrm>
-          <a:prstGeom prst="rect">
-            <a:avLst/>
-          </a:prstGeom>
-          <a:noFill/>
-          <a:ln/>
-        </p:spPr>
-        <p:txBody>
-          <a:bodyPr wrap="square" lIns="0" tIns="0" rIns="0" bIns="0" rtlCol="0" anchor="ctr"/>
-          <a:lstStyle/>
-          <a:p>
-            <a:pPr indent="0" marL="0">
-              <a:buNone/>
-            </a:pPr>
-            <a:r>
-              <a:rPr lang="en-US" sz="1500" dirty="0">
-                <a:solidFill>
-                  <a:srgbClr val="5B6B7A"/>
-                </a:solidFill>
-                <a:latin typeface="Calibri" pitchFamily="34" charset="0"/>
-                <a:ea typeface="Calibri" pitchFamily="34" charset="-122"/>
-                <a:cs typeface="Calibri" pitchFamily="34" charset="-120"/>
-              </a:rPr>
-              <a:t>The same pattern as @Transactional</a:t>
-            </a:r>
-            <a:endParaRPr lang="en-US" sz="1500" dirty="0"/>
-          </a:p>
-        </p:txBody>
-      </p:sp>
-      <p:sp>
-        <p:nvSpPr>
-          <p:cNvPr id="4" name="Shape 2"/>
-          <p:cNvSpPr/>
-          <p:nvPr/>
-        </p:nvSpPr>
-        <p:spPr>
-          <a:xfrm>
-            <a:off x="457200" y="1325880"/>
-            <a:ext cx="8229600" cy="685800"/>
-          </a:xfrm>
-          <a:prstGeom prst="roundRect">
-            <a:avLst>
-              <a:gd name="adj" fmla="val 8000"/>
-            </a:avLst>
-          </a:prstGeom>
-          <a:solidFill>
-            <a:srgbClr val="F1F3F5"/>
-          </a:solidFill>
-          <a:ln w="12700">
-            <a:solidFill>
-              <a:srgbClr val="DEE2E6"/>
-            </a:solidFill>
-            <a:prstDash val="solid"/>
-          </a:ln>
-        </p:spPr>
-      </p:sp>
-      <p:sp>
-        <p:nvSpPr>
-          <p:cNvPr id="5" name="Text 3"/>
-          <p:cNvSpPr txBox="1"/>
-          <p:nvPr/>
-        </p:nvSpPr>
-        <p:spPr>
-          <a:xfrm>
-            <a:off x="621792" y="1435608"/>
-            <a:ext cx="7900416" cy="466344"/>
-          </a:xfrm>
-          <a:prstGeom prst="rect">
-            <a:avLst/>
-          </a:prstGeom>
-          <a:noFill/>
-          <a:ln/>
-        </p:spPr>
-        <p:txBody>
-          <a:bodyPr wrap="square" lIns="0" tIns="0" rIns="0" bIns="0" rtlCol="0" anchor="ctr"/>
-          <a:lstStyle/>
-          <a:p>
-            <a:pPr indent="0" marL="0">
-              <a:lnSpc>
-                <a:spcPct val="115000"/>
-              </a:lnSpc>
-              <a:buNone/>
-            </a:pPr>
-            <a:r>
-              <a:rPr lang="en-US" sz="1200" dirty="0">
-                <a:solidFill>
-                  <a:srgbClr val="22303C"/>
-                </a:solidFill>
-                <a:latin typeface="Courier New" pitchFamily="34" charset="0"/>
-                <a:ea typeface="Courier New" pitchFamily="34" charset="-122"/>
-                <a:cs typeface="Courier New" pitchFamily="34" charset="-120"/>
-              </a:rPr>
-              <a:t>@Retention(RUNTIME) @Target(METHOD)</a:t>
-            </a:r>
-            <a:endParaRPr lang="en-US" sz="1200" dirty="0"/>
-          </a:p>
-          <a:p>
-            <a:pPr indent="0" marL="0">
-              <a:lnSpc>
-                <a:spcPct val="115000"/>
-              </a:lnSpc>
-              <a:buNone/>
-            </a:pPr>
-            <a:r>
-              <a:rPr lang="en-US" sz="1200" dirty="0">
-                <a:solidFill>
-                  <a:srgbClr val="22303C"/>
-                </a:solidFill>
-                <a:latin typeface="Courier New" pitchFamily="34" charset="0"/>
-                <a:ea typeface="Courier New" pitchFamily="34" charset="-122"/>
-                <a:cs typeface="Courier New" pitchFamily="34" charset="-120"/>
-              </a:rPr>
-              <a:t>public @interface Timed { }</a:t>
-            </a:r>
-            <a:endParaRPr lang="en-US" sz="1200" dirty="0"/>
-          </a:p>
-        </p:txBody>
-      </p:sp>
-      <p:sp>
-        <p:nvSpPr>
-          <p:cNvPr id="6" name="Text 4"/>
-          <p:cNvSpPr txBox="1"/>
-          <p:nvPr/>
-        </p:nvSpPr>
-        <p:spPr>
-          <a:xfrm>
-            <a:off x="457200" y="2057400"/>
-            <a:ext cx="3657600" cy="256032"/>
-          </a:xfrm>
-          <a:prstGeom prst="rect">
-            <a:avLst/>
-          </a:prstGeom>
-          <a:noFill/>
-          <a:ln/>
-        </p:spPr>
-        <p:txBody>
-          <a:bodyPr wrap="square" lIns="0" tIns="0" rIns="0" bIns="0" rtlCol="0" anchor="ctr"/>
-          <a:lstStyle/>
-          <a:p>
-            <a:pPr indent="0" marL="0">
-              <a:buNone/>
-            </a:pPr>
-            <a:r>
-              <a:rPr lang="en-US" sz="1200" b="1" dirty="0">
-                <a:solidFill>
-                  <a:srgbClr val="2F9E44"/>
-                </a:solidFill>
-                <a:latin typeface="Calibri" pitchFamily="34" charset="0"/>
-                <a:ea typeface="Calibri" pitchFamily="34" charset="-122"/>
-                <a:cs typeface="Calibri" pitchFamily="34" charset="-120"/>
-              </a:rPr>
-              <a:t>1. The sticker</a:t>
-            </a:r>
-            <a:endParaRPr lang="en-US" sz="1200" dirty="0"/>
-          </a:p>
-        </p:txBody>
-      </p:sp>
-      <p:sp>
-        <p:nvSpPr>
-          <p:cNvPr id="7" name="Shape 5"/>
-          <p:cNvSpPr/>
-          <p:nvPr/>
-        </p:nvSpPr>
-        <p:spPr>
-          <a:xfrm>
-            <a:off x="457200" y="2377440"/>
-            <a:ext cx="8229600" cy="1097280"/>
-          </a:xfrm>
-          <a:prstGeom prst="roundRect">
-            <a:avLst>
-              <a:gd name="adj" fmla="val 5000"/>
-            </a:avLst>
-          </a:prstGeom>
-          <a:solidFill>
-            <a:srgbClr val="F1F3F5"/>
-          </a:solidFill>
-          <a:ln w="12700">
-            <a:solidFill>
-              <a:srgbClr val="DEE2E6"/>
-            </a:solidFill>
-            <a:prstDash val="solid"/>
-          </a:ln>
-        </p:spPr>
-      </p:sp>
-      <p:sp>
-        <p:nvSpPr>
-          <p:cNvPr id="8" name="Text 6"/>
-          <p:cNvSpPr txBox="1"/>
-          <p:nvPr/>
-        </p:nvSpPr>
-        <p:spPr>
-          <a:xfrm>
-            <a:off x="621792" y="2487168"/>
-            <a:ext cx="7900416" cy="877824"/>
-          </a:xfrm>
-          <a:prstGeom prst="rect">
-            <a:avLst/>
-          </a:prstGeom>
-          <a:noFill/>
-          <a:ln/>
-        </p:spPr>
-        <p:txBody>
-          <a:bodyPr wrap="square" lIns="0" tIns="0" rIns="0" bIns="0" rtlCol="0" anchor="ctr"/>
-          <a:lstStyle/>
-          <a:p>
-            <a:pPr indent="0" marL="0">
-              <a:lnSpc>
-                <a:spcPct val="115000"/>
-              </a:lnSpc>
-              <a:buNone/>
-            </a:pPr>
-            <a:r>
-              <a:rPr lang="en-US" sz="1200" dirty="0">
-                <a:solidFill>
-                  <a:srgbClr val="22303C"/>
-                </a:solidFill>
-                <a:latin typeface="Courier New" pitchFamily="34" charset="0"/>
-                <a:ea typeface="Courier New" pitchFamily="34" charset="-122"/>
-                <a:cs typeface="Courier New" pitchFamily="34" charset="-120"/>
-              </a:rPr>
-              <a:t>public Object postProcessAfterInitialization(Object bean, String name) {</a:t>
-            </a:r>
-            <a:endParaRPr lang="en-US" sz="1200" dirty="0"/>
-          </a:p>
-          <a:p>
-            <a:pPr indent="0" marL="0">
-              <a:lnSpc>
-                <a:spcPct val="115000"/>
-              </a:lnSpc>
-              <a:buNone/>
-            </a:pPr>
-            <a:r>
-              <a:rPr lang="en-US" sz="1200" dirty="0">
-                <a:solidFill>
-                  <a:srgbClr val="22303C"/>
-                </a:solidFill>
-                <a:latin typeface="Courier New" pitchFamily="34" charset="0"/>
-                <a:ea typeface="Courier New" pitchFamily="34" charset="-122"/>
-                <a:cs typeface="Courier New" pitchFamily="34" charset="-120"/>
-              </a:rPr>
-              <a:t>    // if a method carries @Timed, return a proxy that measures the call</a:t>
-            </a:r>
-            <a:endParaRPr lang="en-US" sz="1200" dirty="0"/>
-          </a:p>
-          <a:p>
-            <a:pPr indent="0" marL="0">
-              <a:lnSpc>
-                <a:spcPct val="115000"/>
-              </a:lnSpc>
-              <a:buNone/>
-            </a:pPr>
-            <a:r>
-              <a:rPr lang="en-US" sz="1200" dirty="0">
-                <a:solidFill>
-                  <a:srgbClr val="22303C"/>
-                </a:solidFill>
-                <a:latin typeface="Courier New" pitchFamily="34" charset="0"/>
-                <a:ea typeface="Courier New" pitchFamily="34" charset="-122"/>
-                <a:cs typeface="Courier New" pitchFamily="34" charset="-120"/>
-              </a:rPr>
-              <a:t>    return Proxy.newProxyInstance(loader, interfaces, handler);</a:t>
-            </a:r>
-            <a:endParaRPr lang="en-US" sz="1200" dirty="0"/>
-          </a:p>
-          <a:p>
-            <a:pPr indent="0" marL="0">
-              <a:lnSpc>
-                <a:spcPct val="115000"/>
-              </a:lnSpc>
-              <a:buNone/>
-            </a:pPr>
-            <a:r>
-              <a:rPr lang="en-US" sz="1200" dirty="0">
-                <a:solidFill>
-                  <a:srgbClr val="22303C"/>
-                </a:solidFill>
-                <a:latin typeface="Courier New" pitchFamily="34" charset="0"/>
-                <a:ea typeface="Courier New" pitchFamily="34" charset="-122"/>
-                <a:cs typeface="Courier New" pitchFamily="34" charset="-120"/>
-              </a:rPr>
-              <a:t>}</a:t>
-            </a:r>
-            <a:endParaRPr lang="en-US" sz="1200" dirty="0"/>
-          </a:p>
-        </p:txBody>
-      </p:sp>
-      <p:sp>
-        <p:nvSpPr>
-          <p:cNvPr id="9" name="Text 7"/>
-          <p:cNvSpPr txBox="1"/>
-          <p:nvPr/>
-        </p:nvSpPr>
-        <p:spPr>
-          <a:xfrm>
-            <a:off x="457200" y="3520440"/>
-            <a:ext cx="8229600" cy="274320"/>
-          </a:xfrm>
-          <a:prstGeom prst="rect">
-            <a:avLst/>
-          </a:prstGeom>
-          <a:noFill/>
-          <a:ln/>
-        </p:spPr>
-        <p:txBody>
-          <a:bodyPr wrap="square" lIns="0" tIns="0" rIns="0" bIns="0" rtlCol="0" anchor="ctr"/>
-          <a:lstStyle/>
-          <a:p>
-            <a:pPr indent="0" marL="0">
-              <a:buNone/>
-            </a:pPr>
-            <a:r>
-              <a:rPr lang="en-US" sz="1200" b="1" dirty="0">
-                <a:solidFill>
-                  <a:srgbClr val="2F9E44"/>
-                </a:solidFill>
-                <a:latin typeface="Calibri" pitchFamily="34" charset="0"/>
-                <a:ea typeface="Calibri" pitchFamily="34" charset="-122"/>
-                <a:cs typeface="Calibri" pitchFamily="34" charset="-120"/>
-              </a:rPr>
-              <a:t>2. A BeanPostProcessor that wraps the bean   ·   3. A test that proves the duration is logged</a:t>
-            </a:r>
-            <a:endParaRPr lang="en-US" sz="1200" dirty="0"/>
-          </a:p>
-        </p:txBody>
-      </p:sp>
-      <p:sp>
-        <p:nvSpPr>
-          <p:cNvPr id="10" name="Shape 8"/>
-          <p:cNvSpPr/>
-          <p:nvPr/>
-        </p:nvSpPr>
-        <p:spPr>
-          <a:xfrm>
-            <a:off x="457200" y="3931920"/>
-            <a:ext cx="8229600" cy="594360"/>
-          </a:xfrm>
-          <a:prstGeom prst="roundRect">
-            <a:avLst>
-              <a:gd name="adj" fmla="val 12308"/>
-            </a:avLst>
-          </a:prstGeom>
-          <a:solidFill>
-            <a:srgbClr val="FFFFFF"/>
-          </a:solidFill>
-          <a:ln w="25400">
-            <a:solidFill>
-              <a:srgbClr val="2F9E44"/>
-            </a:solidFill>
-            <a:prstDash val="solid"/>
-          </a:ln>
-        </p:spPr>
-      </p:sp>
-      <p:sp>
-        <p:nvSpPr>
-          <p:cNvPr id="11" name="Text 9"/>
-          <p:cNvSpPr txBox="1"/>
-          <p:nvPr/>
-        </p:nvSpPr>
-        <p:spPr>
-          <a:xfrm>
-            <a:off x="640080" y="3931920"/>
-            <a:ext cx="7863840" cy="594360"/>
-          </a:xfrm>
-          <a:prstGeom prst="rect">
-            <a:avLst/>
-          </a:prstGeom>
-          <a:noFill/>
-          <a:ln/>
-        </p:spPr>
-        <p:txBody>
-          <a:bodyPr wrap="square" lIns="0" tIns="0" rIns="0" bIns="0" rtlCol="0" anchor="ctr"/>
-          <a:lstStyle/>
-          <a:p>
-            <a:pPr indent="0" marL="0">
-              <a:buNone/>
-            </a:pPr>
-            <a:r>
-              <a:rPr lang="en-US" sz="1500" b="1" dirty="0">
-                <a:solidFill>
-                  <a:srgbClr val="2F9E44"/>
-                </a:solidFill>
-                <a:latin typeface="Calibri" pitchFamily="34" charset="0"/>
-                <a:ea typeface="Calibri" pitchFamily="34" charset="-122"/>
-                <a:cs typeface="Calibri" pitchFamily="34" charset="-120"/>
-              </a:rPr>
-              <a:t>Thirty lines. You have just written the mechanism behind @Cacheable, @Retry and @Async.</a:t>
-            </a:r>
-            <a:endParaRPr lang="en-US" sz="1500" dirty="0"/>
-          </a:p>
-        </p:txBody>
-      </p:sp>
-    </p:spTree>
-  </p:cSld>
-  <p:clrMapOvr>
-    <a:masterClrMapping/>
-  </p:clrMapOvr>
-</p:sld>
-</file>
-
-<file path=ppt/slides/slide32.xml><?xml version="1.0" encoding="utf-8"?>
-<p:sld xmlns:a="http://schemas.openxmlformats.org/drawingml/2006/main" xmlns:r="http://schemas.openxmlformats.org/officeDocument/2006/relationships" xmlns:p="http://schemas.openxmlformats.org/presentationml/2006/main">
-  <p:cSld name="Slide 32">
-    <p:bg>
-      <p:bgPr>
-        <a:solidFill>
-          <a:srgbClr val="1B2430"/>
-        </a:solidFill>
-      </p:bgPr>
-    </p:bg>
-    <p:spTree>
-      <p:nvGrpSpPr>
-        <p:cNvPr id="1" name=""/>
-        <p:cNvGrpSpPr/>
-        <p:nvPr/>
-      </p:nvGrpSpPr>
-      <p:grpSpPr>
-        <a:xfrm>
-          <a:off x="0" y="0"/>
-          <a:ext cx="0" cy="0"/>
-          <a:chOff x="0" y="0"/>
-          <a:chExt cx="0" cy="0"/>
-        </a:xfrm>
-      </p:grpSpPr>
-      <p:sp>
-        <p:nvSpPr>
-          <p:cNvPr id="2" name="Shape 0"/>
-          <p:cNvSpPr/>
-          <p:nvPr/>
-        </p:nvSpPr>
-        <p:spPr>
-          <a:xfrm>
-            <a:off x="822960" y="1920240"/>
-            <a:ext cx="1005840" cy="1005840"/>
-          </a:xfrm>
-          <a:prstGeom prst="ellipse">
-            <a:avLst/>
-          </a:prstGeom>
-          <a:solidFill>
-            <a:srgbClr val="2F9E44"/>
-          </a:solidFill>
-          <a:ln/>
-        </p:spPr>
-      </p:sp>
-      <p:sp>
-        <p:nvSpPr>
-          <p:cNvPr id="3" name="Text 1"/>
-          <p:cNvSpPr txBox="1"/>
-          <p:nvPr/>
-        </p:nvSpPr>
-        <p:spPr>
-          <a:xfrm>
-            <a:off x="822960" y="1920240"/>
-            <a:ext cx="1005840" cy="1005840"/>
-          </a:xfrm>
-          <a:prstGeom prst="rect">
-            <a:avLst/>
-          </a:prstGeom>
-          <a:noFill/>
-          <a:ln/>
-        </p:spPr>
-        <p:txBody>
-          <a:bodyPr wrap="square" lIns="0" tIns="0" rIns="0" bIns="0" rtlCol="0" anchor="ctr"/>
-          <a:lstStyle/>
-          <a:p>
-            <a:pPr algn="ctr" indent="0" marL="0">
-              <a:buNone/>
-            </a:pPr>
-            <a:r>
-              <a:rPr lang="en-US" sz="4000" b="1" dirty="0">
-                <a:solidFill>
-                  <a:srgbClr val="FFFFFF"/>
-                </a:solidFill>
-                <a:latin typeface="Cambria" pitchFamily="34" charset="0"/>
-                <a:ea typeface="Cambria" pitchFamily="34" charset="-122"/>
-                <a:cs typeface="Cambria" pitchFamily="34" charset="-120"/>
-              </a:rPr>
-              <a:t>6</a:t>
-            </a:r>
-            <a:endParaRPr lang="en-US" sz="4000" dirty="0"/>
-          </a:p>
-        </p:txBody>
-      </p:sp>
-      <p:sp>
-        <p:nvSpPr>
-          <p:cNvPr id="4" name="Text 2"/>
-          <p:cNvSpPr txBox="1"/>
-          <p:nvPr/>
-        </p:nvSpPr>
-        <p:spPr>
-          <a:xfrm>
-            <a:off x="2103120" y="1965960"/>
-            <a:ext cx="6400800" cy="640080"/>
-          </a:xfrm>
-          <a:prstGeom prst="rect">
-            <a:avLst/>
-          </a:prstGeom>
-          <a:noFill/>
-          <a:ln/>
-        </p:spPr>
-        <p:txBody>
-          <a:bodyPr wrap="square" lIns="0" tIns="0" rIns="0" bIns="0" rtlCol="0" anchor="ctr"/>
-          <a:lstStyle/>
-          <a:p>
-            <a:pPr indent="0" marL="0">
-              <a:buNone/>
-            </a:pPr>
-            <a:r>
-              <a:rPr lang="en-US" sz="3000" b="1" dirty="0">
-                <a:solidFill>
-                  <a:srgbClr val="FFFFFF"/>
-                </a:solidFill>
-                <a:latin typeface="Cambria" pitchFamily="34" charset="0"/>
-                <a:ea typeface="Cambria" pitchFamily="34" charset="-122"/>
-                <a:cs typeface="Cambria" pitchFamily="34" charset="-120"/>
-              </a:rPr>
-              <a:t>The Boot layer: auto-configuration</a:t>
-            </a:r>
-            <a:endParaRPr lang="en-US" sz="3000" dirty="0"/>
-          </a:p>
-        </p:txBody>
-      </p:sp>
-      <p:sp>
-        <p:nvSpPr>
-          <p:cNvPr id="5" name="Text 3"/>
-          <p:cNvSpPr txBox="1"/>
-          <p:nvPr/>
-        </p:nvSpPr>
-        <p:spPr>
-          <a:xfrm>
-            <a:off x="2103120" y="2606040"/>
-            <a:ext cx="6400800" cy="457200"/>
-          </a:xfrm>
-          <a:prstGeom prst="rect">
-            <a:avLst/>
-          </a:prstGeom>
-          <a:noFill/>
-          <a:ln/>
-        </p:spPr>
-        <p:txBody>
-          <a:bodyPr wrap="square" lIns="0" tIns="0" rIns="0" bIns="0" rtlCol="0" anchor="ctr"/>
-          <a:lstStyle/>
-          <a:p>
-            <a:pPr indent="0" marL="0">
-              <a:buNone/>
-            </a:pPr>
-            <a:r>
-              <a:rPr lang="en-US" sz="1600" dirty="0">
-                <a:solidFill>
-                  <a:srgbClr val="C7D2DD"/>
-                </a:solidFill>
-                <a:latin typeface="Calibri" pitchFamily="34" charset="0"/>
-                <a:ea typeface="Calibri" pitchFamily="34" charset="-122"/>
-                <a:cs typeface="Calibri" pitchFamily="34" charset="-120"/>
-              </a:rPr>
-              <a:t>How @Conditional decides what gets wired</a:t>
-            </a:r>
-            <a:endParaRPr lang="en-US" sz="1600" dirty="0"/>
-          </a:p>
-        </p:txBody>
-      </p:sp>
-    </p:spTree>
-  </p:cSld>
-  <p:clrMapOvr>
-    <a:masterClrMapping/>
-  </p:clrMapOvr>
-</p:sld>
-</file>
-
-<file path=ppt/slides/slide33.xml><?xml version="1.0" encoding="utf-8"?>
-<p:sld xmlns:a="http://schemas.openxmlformats.org/drawingml/2006/main" xmlns:r="http://schemas.openxmlformats.org/officeDocument/2006/relationships" xmlns:p="http://schemas.openxmlformats.org/presentationml/2006/main">
-  <p:cSld name="Slide 33">
+  <p:cSld name="Slide 34">
     <p:bg>
       <p:bgPr>
         <a:solidFill>
@@ -20382,496 +21931,6 @@
 </p:sld>
 </file>
 
-<file path=ppt/slides/slide34.xml><?xml version="1.0" encoding="utf-8"?>
-<p:sld xmlns:a="http://schemas.openxmlformats.org/drawingml/2006/main" xmlns:r="http://schemas.openxmlformats.org/officeDocument/2006/relationships" xmlns:p="http://schemas.openxmlformats.org/presentationml/2006/main">
-  <p:cSld name="Slide 34">
-    <p:bg>
-      <p:bgPr>
-        <a:solidFill>
-          <a:srgbClr val="FFFFFF"/>
-        </a:solidFill>
-      </p:bgPr>
-    </p:bg>
-    <p:spTree>
-      <p:nvGrpSpPr>
-        <p:cNvPr id="1" name=""/>
-        <p:cNvGrpSpPr/>
-        <p:nvPr/>
-      </p:nvGrpSpPr>
-      <p:grpSpPr>
-        <a:xfrm>
-          <a:off x="0" y="0"/>
-          <a:ext cx="0" cy="0"/>
-          <a:chOff x="0" y="0"/>
-          <a:chExt cx="0" cy="0"/>
-        </a:xfrm>
-      </p:grpSpPr>
-      <p:sp>
-        <p:nvSpPr>
-          <p:cNvPr id="2" name="Text 0"/>
-          <p:cNvSpPr txBox="1"/>
-          <p:nvPr/>
-        </p:nvSpPr>
-        <p:spPr>
-          <a:xfrm>
-            <a:off x="457200" y="292608"/>
-            <a:ext cx="8229600" cy="713232"/>
-          </a:xfrm>
-          <a:prstGeom prst="rect">
-            <a:avLst/>
-          </a:prstGeom>
-          <a:noFill/>
-          <a:ln/>
-        </p:spPr>
-        <p:txBody>
-          <a:bodyPr wrap="square" lIns="0" tIns="0" rIns="0" bIns="0" rtlCol="0" anchor="t"/>
-          <a:lstStyle/>
-          <a:p>
-            <a:pPr indent="0" marL="0">
-              <a:buNone/>
-            </a:pPr>
-            <a:r>
-              <a:rPr lang="en-US" sz="3000" b="1" dirty="0">
-                <a:solidFill>
-                  <a:srgbClr val="22303C"/>
-                </a:solidFill>
-                <a:latin typeface="Cambria" pitchFamily="34" charset="0"/>
-                <a:ea typeface="Cambria" pitchFamily="34" charset="-122"/>
-                <a:cs typeface="Cambria" pitchFamily="34" charset="-120"/>
-              </a:rPr>
-              <a:t>Two rules, and everything follows</a:t>
-            </a:r>
-            <a:endParaRPr lang="en-US" sz="3000" dirty="0"/>
-          </a:p>
-        </p:txBody>
-      </p:sp>
-      <p:sp>
-        <p:nvSpPr>
-          <p:cNvPr id="3" name="Shape 1"/>
-          <p:cNvSpPr/>
-          <p:nvPr/>
-        </p:nvSpPr>
-        <p:spPr>
-          <a:xfrm>
-            <a:off x="457200" y="1371600"/>
-            <a:ext cx="3977640" cy="1371600"/>
-          </a:xfrm>
-          <a:prstGeom prst="roundRect">
-            <a:avLst>
-              <a:gd name="adj" fmla="val 5333"/>
-            </a:avLst>
-          </a:prstGeom>
-          <a:solidFill>
-            <a:srgbClr val="F1F3F5"/>
-          </a:solidFill>
-          <a:ln w="12700">
-            <a:solidFill>
-              <a:srgbClr val="DEE2E6"/>
-            </a:solidFill>
-            <a:prstDash val="solid"/>
-          </a:ln>
-        </p:spPr>
-      </p:sp>
-      <p:sp>
-        <p:nvSpPr>
-          <p:cNvPr id="4" name="Text 2"/>
-          <p:cNvSpPr txBox="1"/>
-          <p:nvPr/>
-        </p:nvSpPr>
-        <p:spPr>
-          <a:xfrm>
-            <a:off x="640080" y="1508760"/>
-            <a:ext cx="3657600" cy="640080"/>
-          </a:xfrm>
-          <a:prstGeom prst="rect">
-            <a:avLst/>
-          </a:prstGeom>
-          <a:noFill/>
-          <a:ln/>
-        </p:spPr>
-        <p:txBody>
-          <a:bodyPr wrap="square" lIns="0" tIns="0" rIns="0" bIns="0" rtlCol="0" anchor="ctr"/>
-          <a:lstStyle/>
-          <a:p>
-            <a:pPr indent="0" marL="0">
-              <a:buNone/>
-            </a:pPr>
-            <a:r>
-              <a:rPr lang="en-US" sz="1600" b="1" dirty="0">
-                <a:solidFill>
-                  <a:srgbClr val="22303C"/>
-                </a:solidFill>
-                <a:latin typeface="Calibri" pitchFamily="34" charset="0"/>
-                <a:ea typeface="Calibri" pitchFamily="34" charset="-122"/>
-                <a:cs typeface="Calibri" pitchFamily="34" charset="-120"/>
-              </a:rPr>
-              <a:t>1. Conditions read definitions,</a:t>
-            </a:r>
-            <a:endParaRPr lang="en-US" sz="1600" dirty="0"/>
-          </a:p>
-          <a:p>
-            <a:pPr indent="0" marL="0">
-              <a:buNone/>
-            </a:pPr>
-            <a:r>
-              <a:rPr lang="en-US" sz="1600" b="1" dirty="0">
-                <a:solidFill>
-                  <a:srgbClr val="22303C"/>
-                </a:solidFill>
-                <a:latin typeface="Calibri" pitchFamily="34" charset="0"/>
-                <a:ea typeface="Calibri" pitchFamily="34" charset="-122"/>
-                <a:cs typeface="Calibri" pitchFamily="34" charset="-120"/>
-              </a:rPr>
-              <a:t>never instances</a:t>
-            </a:r>
-            <a:endParaRPr lang="en-US" sz="1600" dirty="0"/>
-          </a:p>
-        </p:txBody>
-      </p:sp>
-      <p:sp>
-        <p:nvSpPr>
-          <p:cNvPr id="5" name="Text 3"/>
-          <p:cNvSpPr txBox="1"/>
-          <p:nvPr/>
-        </p:nvSpPr>
-        <p:spPr>
-          <a:xfrm>
-            <a:off x="640080" y="2148840"/>
-            <a:ext cx="3657600" cy="548640"/>
-          </a:xfrm>
-          <a:prstGeom prst="rect">
-            <a:avLst/>
-          </a:prstGeom>
-          <a:noFill/>
-          <a:ln/>
-        </p:spPr>
-        <p:txBody>
-          <a:bodyPr wrap="square" lIns="0" tIns="0" rIns="0" bIns="0" rtlCol="0" anchor="ctr"/>
-          <a:lstStyle/>
-          <a:p>
-            <a:pPr indent="0" marL="0">
-              <a:buNone/>
-            </a:pPr>
-            <a:r>
-              <a:rPr lang="en-US" sz="1300" dirty="0">
-                <a:solidFill>
-                  <a:srgbClr val="5B6B7A"/>
-                </a:solidFill>
-                <a:latin typeface="Calibri" pitchFamily="34" charset="0"/>
-                <a:ea typeface="Calibri" pitchFamily="34" charset="-122"/>
-                <a:cs typeface="Calibri" pitchFamily="34" charset="-120"/>
-              </a:rPr>
-              <a:t>Deciding whether a bean should exist must not create beans, or the question answers itself.</a:t>
-            </a:r>
-            <a:endParaRPr lang="en-US" sz="1300" dirty="0"/>
-          </a:p>
-        </p:txBody>
-      </p:sp>
-      <p:sp>
-        <p:nvSpPr>
-          <p:cNvPr id="6" name="Shape 4"/>
-          <p:cNvSpPr/>
-          <p:nvPr/>
-        </p:nvSpPr>
-        <p:spPr>
-          <a:xfrm>
-            <a:off x="4709160" y="1371600"/>
-            <a:ext cx="3977640" cy="1371600"/>
-          </a:xfrm>
-          <a:prstGeom prst="roundRect">
-            <a:avLst>
-              <a:gd name="adj" fmla="val 5333"/>
-            </a:avLst>
-          </a:prstGeom>
-          <a:solidFill>
-            <a:srgbClr val="F1F3F5"/>
-          </a:solidFill>
-          <a:ln w="12700">
-            <a:solidFill>
-              <a:srgbClr val="DEE2E6"/>
-            </a:solidFill>
-            <a:prstDash val="solid"/>
-          </a:ln>
-        </p:spPr>
-      </p:sp>
-      <p:sp>
-        <p:nvSpPr>
-          <p:cNvPr id="7" name="Text 5"/>
-          <p:cNvSpPr txBox="1"/>
-          <p:nvPr/>
-        </p:nvSpPr>
-        <p:spPr>
-          <a:xfrm>
-            <a:off x="4892040" y="1508760"/>
-            <a:ext cx="3657600" cy="640080"/>
-          </a:xfrm>
-          <a:prstGeom prst="rect">
-            <a:avLst/>
-          </a:prstGeom>
-          <a:noFill/>
-          <a:ln/>
-        </p:spPr>
-        <p:txBody>
-          <a:bodyPr wrap="square" lIns="0" tIns="0" rIns="0" bIns="0" rtlCol="0" anchor="ctr"/>
-          <a:lstStyle/>
-          <a:p>
-            <a:pPr indent="0" marL="0">
-              <a:buNone/>
-            </a:pPr>
-            <a:r>
-              <a:rPr lang="en-US" sz="1600" b="1" dirty="0">
-                <a:solidFill>
-                  <a:srgbClr val="22303C"/>
-                </a:solidFill>
-                <a:latin typeface="Calibri" pitchFamily="34" charset="0"/>
-                <a:ea typeface="Calibri" pitchFamily="34" charset="-122"/>
-                <a:cs typeface="Calibri" pitchFamily="34" charset="-120"/>
-              </a:rPr>
-              <a:t>2. Auto-configurations</a:t>
-            </a:r>
-            <a:endParaRPr lang="en-US" sz="1600" dirty="0"/>
-          </a:p>
-          <a:p>
-            <a:pPr indent="0" marL="0">
-              <a:buNone/>
-            </a:pPr>
-            <a:r>
-              <a:rPr lang="en-US" sz="1600" b="1" dirty="0">
-                <a:solidFill>
-                  <a:srgbClr val="22303C"/>
-                </a:solidFill>
-                <a:latin typeface="Calibri" pitchFamily="34" charset="0"/>
-                <a:ea typeface="Calibri" pitchFamily="34" charset="-122"/>
-                <a:cs typeface="Calibri" pitchFamily="34" charset="-120"/>
-              </a:rPr>
-              <a:t>register last</a:t>
-            </a:r>
-            <a:endParaRPr lang="en-US" sz="1600" dirty="0"/>
-          </a:p>
-        </p:txBody>
-      </p:sp>
-      <p:sp>
-        <p:nvSpPr>
-          <p:cNvPr id="8" name="Text 6"/>
-          <p:cNvSpPr txBox="1"/>
-          <p:nvPr/>
-        </p:nvSpPr>
-        <p:spPr>
-          <a:xfrm>
-            <a:off x="4892040" y="2148840"/>
-            <a:ext cx="3657600" cy="548640"/>
-          </a:xfrm>
-          <a:prstGeom prst="rect">
-            <a:avLst/>
-          </a:prstGeom>
-          <a:noFill/>
-          <a:ln/>
-        </p:spPr>
-        <p:txBody>
-          <a:bodyPr wrap="square" lIns="0" tIns="0" rIns="0" bIns="0" rtlCol="0" anchor="ctr"/>
-          <a:lstStyle/>
-          <a:p>
-            <a:pPr indent="0" marL="0">
-              <a:buNone/>
-            </a:pPr>
-            <a:r>
-              <a:rPr lang="en-US" sz="1300" dirty="0">
-                <a:solidFill>
-                  <a:srgbClr val="5B6B7A"/>
-                </a:solidFill>
-                <a:latin typeface="Calibri" pitchFamily="34" charset="0"/>
-                <a:ea typeface="Calibri" pitchFamily="34" charset="-122"/>
-                <a:cs typeface="Calibri" pitchFamily="34" charset="-120"/>
-              </a:rPr>
-              <a:t>Only then can @ConditionalOnMissingBean mean "unless you declared your own".</a:t>
-            </a:r>
-            <a:endParaRPr lang="en-US" sz="1300" dirty="0"/>
-          </a:p>
-        </p:txBody>
-      </p:sp>
-      <p:sp>
-        <p:nvSpPr>
-          <p:cNvPr id="9" name="Shape 7"/>
-          <p:cNvSpPr/>
-          <p:nvPr/>
-        </p:nvSpPr>
-        <p:spPr>
-          <a:xfrm>
-            <a:off x="457200" y="2926080"/>
-            <a:ext cx="8229600" cy="960120"/>
-          </a:xfrm>
-          <a:prstGeom prst="roundRect">
-            <a:avLst>
-              <a:gd name="adj" fmla="val 5714"/>
-            </a:avLst>
-          </a:prstGeom>
-          <a:solidFill>
-            <a:srgbClr val="F1F3F5"/>
-          </a:solidFill>
-          <a:ln w="12700">
-            <a:solidFill>
-              <a:srgbClr val="DEE2E6"/>
-            </a:solidFill>
-            <a:prstDash val="solid"/>
-          </a:ln>
-        </p:spPr>
-      </p:sp>
-      <p:sp>
-        <p:nvSpPr>
-          <p:cNvPr id="10" name="Text 8"/>
-          <p:cNvSpPr txBox="1"/>
-          <p:nvPr/>
-        </p:nvSpPr>
-        <p:spPr>
-          <a:xfrm>
-            <a:off x="621792" y="3035808"/>
-            <a:ext cx="7900416" cy="740664"/>
-          </a:xfrm>
-          <a:prstGeom prst="rect">
-            <a:avLst/>
-          </a:prstGeom>
-          <a:noFill/>
-          <a:ln/>
-        </p:spPr>
-        <p:txBody>
-          <a:bodyPr wrap="square" lIns="0" tIns="0" rIns="0" bIns="0" rtlCol="0" anchor="ctr"/>
-          <a:lstStyle/>
-          <a:p>
-            <a:pPr indent="0" marL="0">
-              <a:lnSpc>
-                <a:spcPct val="115000"/>
-              </a:lnSpc>
-              <a:buNone/>
-            </a:pPr>
-            <a:r>
-              <a:rPr lang="en-US" sz="1100" dirty="0">
-                <a:solidFill>
-                  <a:srgbClr val="22303C"/>
-                </a:solidFill>
-                <a:latin typeface="Courier New" pitchFamily="34" charset="0"/>
-                <a:ea typeface="Courier New" pitchFamily="34" charset="-122"/>
-                <a:cs typeface="Courier New" pitchFamily="34" charset="-120"/>
-              </a:rPr>
-              <a:t>@Bean</a:t>
-            </a:r>
-            <a:endParaRPr lang="en-US" sz="1100" dirty="0"/>
-          </a:p>
-          <a:p>
-            <a:pPr indent="0" marL="0">
-              <a:lnSpc>
-                <a:spcPct val="115000"/>
-              </a:lnSpc>
-              <a:buNone/>
-            </a:pPr>
-            <a:r>
-              <a:rPr lang="en-US" sz="1100" dirty="0">
-                <a:solidFill>
-                  <a:srgbClr val="22303C"/>
-                </a:solidFill>
-                <a:latin typeface="Courier New" pitchFamily="34" charset="0"/>
-                <a:ea typeface="Courier New" pitchFamily="34" charset="-122"/>
-                <a:cs typeface="Courier New" pitchFamily="34" charset="-120"/>
-              </a:rPr>
-              <a:t>@ConditionalOnMissingBean</a:t>
-            </a:r>
-            <a:endParaRPr lang="en-US" sz="1100" dirty="0"/>
-          </a:p>
-          <a:p>
-            <a:pPr indent="0" marL="0">
-              <a:lnSpc>
-                <a:spcPct val="115000"/>
-              </a:lnSpc>
-              <a:buNone/>
-            </a:pPr>
-            <a:r>
-              <a:rPr lang="en-US" sz="1100" dirty="0">
-                <a:solidFill>
-                  <a:srgbClr val="22303C"/>
-                </a:solidFill>
-                <a:latin typeface="Courier New" pitchFamily="34" charset="0"/>
-                <a:ea typeface="Courier New" pitchFamily="34" charset="-122"/>
-                <a:cs typeface="Courier New" pitchFamily="34" charset="-120"/>
-              </a:rPr>
-              <a:t>public Notifier notifier() { return message -&gt; System.out.println("NOTIFY   " + message); }</a:t>
-            </a:r>
-            <a:endParaRPr lang="en-US" sz="1100" dirty="0"/>
-          </a:p>
-        </p:txBody>
-      </p:sp>
-      <p:sp>
-        <p:nvSpPr>
-          <p:cNvPr id="11" name="Shape 9"/>
-          <p:cNvSpPr/>
-          <p:nvPr/>
-        </p:nvSpPr>
-        <p:spPr>
-          <a:xfrm>
-            <a:off x="457200" y="4069080"/>
-            <a:ext cx="8229600" cy="594360"/>
-          </a:xfrm>
-          <a:prstGeom prst="roundRect">
-            <a:avLst>
-              <a:gd name="adj" fmla="val 12308"/>
-            </a:avLst>
-          </a:prstGeom>
-          <a:solidFill>
-            <a:srgbClr val="FFFFFF"/>
-          </a:solidFill>
-          <a:ln w="25400">
-            <a:solidFill>
-              <a:srgbClr val="E8590C"/>
-            </a:solidFill>
-            <a:prstDash val="solid"/>
-          </a:ln>
-        </p:spPr>
-      </p:sp>
-      <p:sp>
-        <p:nvSpPr>
-          <p:cNvPr id="12" name="Text 10"/>
-          <p:cNvSpPr txBox="1"/>
-          <p:nvPr/>
-        </p:nvSpPr>
-        <p:spPr>
-          <a:xfrm>
-            <a:off x="640080" y="4069080"/>
-            <a:ext cx="7863840" cy="594360"/>
-          </a:xfrm>
-          <a:prstGeom prst="rect">
-            <a:avLst/>
-          </a:prstGeom>
-          <a:noFill/>
-          <a:ln/>
-        </p:spPr>
-        <p:txBody>
-          <a:bodyPr wrap="square" lIns="0" tIns="0" rIns="0" bIns="0" rtlCol="0" anchor="ctr"/>
-          <a:lstStyle/>
-          <a:p>
-            <a:pPr indent="0" marL="0">
-              <a:buNone/>
-            </a:pPr>
-            <a:r>
-              <a:rPr lang="en-US" sz="1500" b="1" dirty="0">
-                <a:solidFill>
-                  <a:srgbClr val="E8590C"/>
-                </a:solidFill>
-                <a:latin typeface="Calibri" pitchFamily="34" charset="0"/>
-                <a:ea typeface="Calibri" pitchFamily="34" charset="-122"/>
-                <a:cs typeface="Calibri" pitchFamily="34" charset="-120"/>
-              </a:rPr>
-              <a:t>Same classes, opposite registration order, different application. There is a test for it.</a:t>
-            </a:r>
-            <a:endParaRPr lang="en-US" sz="1500" dirty="0"/>
-          </a:p>
-        </p:txBody>
-      </p:sp>
-    </p:spTree>
-  </p:cSld>
-  <p:clrMapOvr>
-    <a:masterClrMapping/>
-  </p:clrMapOvr>
-</p:sld>
-</file>
-
 <file path=ppt/slides/slide35.xml><?xml version="1.0" encoding="utf-8"?>
 <p:sld xmlns:a="http://schemas.openxmlformats.org/drawingml/2006/main" xmlns:r="http://schemas.openxmlformats.org/officeDocument/2006/relationships" xmlns:p="http://schemas.openxmlformats.org/presentationml/2006/main">
   <p:cSld name="Slide 35">
@@ -20929,6 +21988,496 @@
                 <a:ea typeface="Cambria" pitchFamily="34" charset="-122"/>
                 <a:cs typeface="Cambria" pitchFamily="34" charset="-120"/>
               </a:rPr>
+              <a:t>Two rules, and everything follows</a:t>
+            </a:r>
+            <a:endParaRPr lang="en-US" sz="3000" dirty="0"/>
+          </a:p>
+        </p:txBody>
+      </p:sp>
+      <p:sp>
+        <p:nvSpPr>
+          <p:cNvPr id="3" name="Shape 1"/>
+          <p:cNvSpPr/>
+          <p:nvPr/>
+        </p:nvSpPr>
+        <p:spPr>
+          <a:xfrm>
+            <a:off x="457200" y="1371600"/>
+            <a:ext cx="3977640" cy="1371600"/>
+          </a:xfrm>
+          <a:prstGeom prst="roundRect">
+            <a:avLst>
+              <a:gd name="adj" fmla="val 5333"/>
+            </a:avLst>
+          </a:prstGeom>
+          <a:solidFill>
+            <a:srgbClr val="F1F3F5"/>
+          </a:solidFill>
+          <a:ln w="12700">
+            <a:solidFill>
+              <a:srgbClr val="DEE2E6"/>
+            </a:solidFill>
+            <a:prstDash val="solid"/>
+          </a:ln>
+        </p:spPr>
+      </p:sp>
+      <p:sp>
+        <p:nvSpPr>
+          <p:cNvPr id="4" name="Text 2"/>
+          <p:cNvSpPr txBox="1"/>
+          <p:nvPr/>
+        </p:nvSpPr>
+        <p:spPr>
+          <a:xfrm>
+            <a:off x="640080" y="1508760"/>
+            <a:ext cx="3657600" cy="640080"/>
+          </a:xfrm>
+          <a:prstGeom prst="rect">
+            <a:avLst/>
+          </a:prstGeom>
+          <a:noFill/>
+          <a:ln/>
+        </p:spPr>
+        <p:txBody>
+          <a:bodyPr wrap="square" lIns="0" tIns="0" rIns="0" bIns="0" rtlCol="0" anchor="ctr"/>
+          <a:lstStyle/>
+          <a:p>
+            <a:pPr indent="0" marL="0">
+              <a:buNone/>
+            </a:pPr>
+            <a:r>
+              <a:rPr lang="en-US" sz="1600" b="1" dirty="0">
+                <a:solidFill>
+                  <a:srgbClr val="22303C"/>
+                </a:solidFill>
+                <a:latin typeface="Calibri" pitchFamily="34" charset="0"/>
+                <a:ea typeface="Calibri" pitchFamily="34" charset="-122"/>
+                <a:cs typeface="Calibri" pitchFamily="34" charset="-120"/>
+              </a:rPr>
+              <a:t>1. Conditions read definitions,</a:t>
+            </a:r>
+            <a:endParaRPr lang="en-US" sz="1600" dirty="0"/>
+          </a:p>
+          <a:p>
+            <a:pPr indent="0" marL="0">
+              <a:buNone/>
+            </a:pPr>
+            <a:r>
+              <a:rPr lang="en-US" sz="1600" b="1" dirty="0">
+                <a:solidFill>
+                  <a:srgbClr val="22303C"/>
+                </a:solidFill>
+                <a:latin typeface="Calibri" pitchFamily="34" charset="0"/>
+                <a:ea typeface="Calibri" pitchFamily="34" charset="-122"/>
+                <a:cs typeface="Calibri" pitchFamily="34" charset="-120"/>
+              </a:rPr>
+              <a:t>never instances</a:t>
+            </a:r>
+            <a:endParaRPr lang="en-US" sz="1600" dirty="0"/>
+          </a:p>
+        </p:txBody>
+      </p:sp>
+      <p:sp>
+        <p:nvSpPr>
+          <p:cNvPr id="5" name="Text 3"/>
+          <p:cNvSpPr txBox="1"/>
+          <p:nvPr/>
+        </p:nvSpPr>
+        <p:spPr>
+          <a:xfrm>
+            <a:off x="640080" y="2148840"/>
+            <a:ext cx="3657600" cy="548640"/>
+          </a:xfrm>
+          <a:prstGeom prst="rect">
+            <a:avLst/>
+          </a:prstGeom>
+          <a:noFill/>
+          <a:ln/>
+        </p:spPr>
+        <p:txBody>
+          <a:bodyPr wrap="square" lIns="0" tIns="0" rIns="0" bIns="0" rtlCol="0" anchor="ctr"/>
+          <a:lstStyle/>
+          <a:p>
+            <a:pPr indent="0" marL="0">
+              <a:buNone/>
+            </a:pPr>
+            <a:r>
+              <a:rPr lang="en-US" sz="1300" dirty="0">
+                <a:solidFill>
+                  <a:srgbClr val="5B6B7A"/>
+                </a:solidFill>
+                <a:latin typeface="Calibri" pitchFamily="34" charset="0"/>
+                <a:ea typeface="Calibri" pitchFamily="34" charset="-122"/>
+                <a:cs typeface="Calibri" pitchFamily="34" charset="-120"/>
+              </a:rPr>
+              <a:t>Deciding whether a bean should exist must not create beans, or the question answers itself.</a:t>
+            </a:r>
+            <a:endParaRPr lang="en-US" sz="1300" dirty="0"/>
+          </a:p>
+        </p:txBody>
+      </p:sp>
+      <p:sp>
+        <p:nvSpPr>
+          <p:cNvPr id="6" name="Shape 4"/>
+          <p:cNvSpPr/>
+          <p:nvPr/>
+        </p:nvSpPr>
+        <p:spPr>
+          <a:xfrm>
+            <a:off x="4709160" y="1371600"/>
+            <a:ext cx="3977640" cy="1371600"/>
+          </a:xfrm>
+          <a:prstGeom prst="roundRect">
+            <a:avLst>
+              <a:gd name="adj" fmla="val 5333"/>
+            </a:avLst>
+          </a:prstGeom>
+          <a:solidFill>
+            <a:srgbClr val="F1F3F5"/>
+          </a:solidFill>
+          <a:ln w="12700">
+            <a:solidFill>
+              <a:srgbClr val="DEE2E6"/>
+            </a:solidFill>
+            <a:prstDash val="solid"/>
+          </a:ln>
+        </p:spPr>
+      </p:sp>
+      <p:sp>
+        <p:nvSpPr>
+          <p:cNvPr id="7" name="Text 5"/>
+          <p:cNvSpPr txBox="1"/>
+          <p:nvPr/>
+        </p:nvSpPr>
+        <p:spPr>
+          <a:xfrm>
+            <a:off x="4892040" y="1508760"/>
+            <a:ext cx="3657600" cy="640080"/>
+          </a:xfrm>
+          <a:prstGeom prst="rect">
+            <a:avLst/>
+          </a:prstGeom>
+          <a:noFill/>
+          <a:ln/>
+        </p:spPr>
+        <p:txBody>
+          <a:bodyPr wrap="square" lIns="0" tIns="0" rIns="0" bIns="0" rtlCol="0" anchor="ctr"/>
+          <a:lstStyle/>
+          <a:p>
+            <a:pPr indent="0" marL="0">
+              <a:buNone/>
+            </a:pPr>
+            <a:r>
+              <a:rPr lang="en-US" sz="1600" b="1" dirty="0">
+                <a:solidFill>
+                  <a:srgbClr val="22303C"/>
+                </a:solidFill>
+                <a:latin typeface="Calibri" pitchFamily="34" charset="0"/>
+                <a:ea typeface="Calibri" pitchFamily="34" charset="-122"/>
+                <a:cs typeface="Calibri" pitchFamily="34" charset="-120"/>
+              </a:rPr>
+              <a:t>2. Auto-configurations</a:t>
+            </a:r>
+            <a:endParaRPr lang="en-US" sz="1600" dirty="0"/>
+          </a:p>
+          <a:p>
+            <a:pPr indent="0" marL="0">
+              <a:buNone/>
+            </a:pPr>
+            <a:r>
+              <a:rPr lang="en-US" sz="1600" b="1" dirty="0">
+                <a:solidFill>
+                  <a:srgbClr val="22303C"/>
+                </a:solidFill>
+                <a:latin typeface="Calibri" pitchFamily="34" charset="0"/>
+                <a:ea typeface="Calibri" pitchFamily="34" charset="-122"/>
+                <a:cs typeface="Calibri" pitchFamily="34" charset="-120"/>
+              </a:rPr>
+              <a:t>register last</a:t>
+            </a:r>
+            <a:endParaRPr lang="en-US" sz="1600" dirty="0"/>
+          </a:p>
+        </p:txBody>
+      </p:sp>
+      <p:sp>
+        <p:nvSpPr>
+          <p:cNvPr id="8" name="Text 6"/>
+          <p:cNvSpPr txBox="1"/>
+          <p:nvPr/>
+        </p:nvSpPr>
+        <p:spPr>
+          <a:xfrm>
+            <a:off x="4892040" y="2148840"/>
+            <a:ext cx="3657600" cy="548640"/>
+          </a:xfrm>
+          <a:prstGeom prst="rect">
+            <a:avLst/>
+          </a:prstGeom>
+          <a:noFill/>
+          <a:ln/>
+        </p:spPr>
+        <p:txBody>
+          <a:bodyPr wrap="square" lIns="0" tIns="0" rIns="0" bIns="0" rtlCol="0" anchor="ctr"/>
+          <a:lstStyle/>
+          <a:p>
+            <a:pPr indent="0" marL="0">
+              <a:buNone/>
+            </a:pPr>
+            <a:r>
+              <a:rPr lang="en-US" sz="1300" dirty="0">
+                <a:solidFill>
+                  <a:srgbClr val="5B6B7A"/>
+                </a:solidFill>
+                <a:latin typeface="Calibri" pitchFamily="34" charset="0"/>
+                <a:ea typeface="Calibri" pitchFamily="34" charset="-122"/>
+                <a:cs typeface="Calibri" pitchFamily="34" charset="-120"/>
+              </a:rPr>
+              <a:t>Only then can @ConditionalOnMissingBean mean "unless you declared your own".</a:t>
+            </a:r>
+            <a:endParaRPr lang="en-US" sz="1300" dirty="0"/>
+          </a:p>
+        </p:txBody>
+      </p:sp>
+      <p:sp>
+        <p:nvSpPr>
+          <p:cNvPr id="9" name="Shape 7"/>
+          <p:cNvSpPr/>
+          <p:nvPr/>
+        </p:nvSpPr>
+        <p:spPr>
+          <a:xfrm>
+            <a:off x="457200" y="2926080"/>
+            <a:ext cx="8229600" cy="960120"/>
+          </a:xfrm>
+          <a:prstGeom prst="roundRect">
+            <a:avLst>
+              <a:gd name="adj" fmla="val 5714"/>
+            </a:avLst>
+          </a:prstGeom>
+          <a:solidFill>
+            <a:srgbClr val="F1F3F5"/>
+          </a:solidFill>
+          <a:ln w="12700">
+            <a:solidFill>
+              <a:srgbClr val="DEE2E6"/>
+            </a:solidFill>
+            <a:prstDash val="solid"/>
+          </a:ln>
+        </p:spPr>
+      </p:sp>
+      <p:sp>
+        <p:nvSpPr>
+          <p:cNvPr id="10" name="Text 8"/>
+          <p:cNvSpPr txBox="1"/>
+          <p:nvPr/>
+        </p:nvSpPr>
+        <p:spPr>
+          <a:xfrm>
+            <a:off x="621792" y="3035808"/>
+            <a:ext cx="7900416" cy="740664"/>
+          </a:xfrm>
+          <a:prstGeom prst="rect">
+            <a:avLst/>
+          </a:prstGeom>
+          <a:noFill/>
+          <a:ln/>
+        </p:spPr>
+        <p:txBody>
+          <a:bodyPr wrap="square" lIns="0" tIns="0" rIns="0" bIns="0" rtlCol="0" anchor="ctr"/>
+          <a:lstStyle/>
+          <a:p>
+            <a:pPr indent="0" marL="0">
+              <a:lnSpc>
+                <a:spcPct val="115000"/>
+              </a:lnSpc>
+              <a:buNone/>
+            </a:pPr>
+            <a:r>
+              <a:rPr lang="en-US" sz="1100" dirty="0">
+                <a:solidFill>
+                  <a:srgbClr val="22303C"/>
+                </a:solidFill>
+                <a:latin typeface="Courier New" pitchFamily="34" charset="0"/>
+                <a:ea typeface="Courier New" pitchFamily="34" charset="-122"/>
+                <a:cs typeface="Courier New" pitchFamily="34" charset="-120"/>
+              </a:rPr>
+              <a:t>@Bean</a:t>
+            </a:r>
+            <a:endParaRPr lang="en-US" sz="1100" dirty="0"/>
+          </a:p>
+          <a:p>
+            <a:pPr indent="0" marL="0">
+              <a:lnSpc>
+                <a:spcPct val="115000"/>
+              </a:lnSpc>
+              <a:buNone/>
+            </a:pPr>
+            <a:r>
+              <a:rPr lang="en-US" sz="1100" dirty="0">
+                <a:solidFill>
+                  <a:srgbClr val="22303C"/>
+                </a:solidFill>
+                <a:latin typeface="Courier New" pitchFamily="34" charset="0"/>
+                <a:ea typeface="Courier New" pitchFamily="34" charset="-122"/>
+                <a:cs typeface="Courier New" pitchFamily="34" charset="-120"/>
+              </a:rPr>
+              <a:t>@ConditionalOnMissingBean</a:t>
+            </a:r>
+            <a:endParaRPr lang="en-US" sz="1100" dirty="0"/>
+          </a:p>
+          <a:p>
+            <a:pPr indent="0" marL="0">
+              <a:lnSpc>
+                <a:spcPct val="115000"/>
+              </a:lnSpc>
+              <a:buNone/>
+            </a:pPr>
+            <a:r>
+              <a:rPr lang="en-US" sz="1100" dirty="0">
+                <a:solidFill>
+                  <a:srgbClr val="22303C"/>
+                </a:solidFill>
+                <a:latin typeface="Courier New" pitchFamily="34" charset="0"/>
+                <a:ea typeface="Courier New" pitchFamily="34" charset="-122"/>
+                <a:cs typeface="Courier New" pitchFamily="34" charset="-120"/>
+              </a:rPr>
+              <a:t>public Notifier notifier() { return message -&gt; System.out.println("NOTIFY   " + message); }</a:t>
+            </a:r>
+            <a:endParaRPr lang="en-US" sz="1100" dirty="0"/>
+          </a:p>
+        </p:txBody>
+      </p:sp>
+      <p:sp>
+        <p:nvSpPr>
+          <p:cNvPr id="11" name="Shape 9"/>
+          <p:cNvSpPr/>
+          <p:nvPr/>
+        </p:nvSpPr>
+        <p:spPr>
+          <a:xfrm>
+            <a:off x="457200" y="4069080"/>
+            <a:ext cx="8229600" cy="594360"/>
+          </a:xfrm>
+          <a:prstGeom prst="roundRect">
+            <a:avLst>
+              <a:gd name="adj" fmla="val 12308"/>
+            </a:avLst>
+          </a:prstGeom>
+          <a:solidFill>
+            <a:srgbClr val="FFFFFF"/>
+          </a:solidFill>
+          <a:ln w="25400">
+            <a:solidFill>
+              <a:srgbClr val="E8590C"/>
+            </a:solidFill>
+            <a:prstDash val="solid"/>
+          </a:ln>
+        </p:spPr>
+      </p:sp>
+      <p:sp>
+        <p:nvSpPr>
+          <p:cNvPr id="12" name="Text 10"/>
+          <p:cNvSpPr txBox="1"/>
+          <p:nvPr/>
+        </p:nvSpPr>
+        <p:spPr>
+          <a:xfrm>
+            <a:off x="640080" y="4069080"/>
+            <a:ext cx="7863840" cy="594360"/>
+          </a:xfrm>
+          <a:prstGeom prst="rect">
+            <a:avLst/>
+          </a:prstGeom>
+          <a:noFill/>
+          <a:ln/>
+        </p:spPr>
+        <p:txBody>
+          <a:bodyPr wrap="square" lIns="0" tIns="0" rIns="0" bIns="0" rtlCol="0" anchor="ctr"/>
+          <a:lstStyle/>
+          <a:p>
+            <a:pPr indent="0" marL="0">
+              <a:buNone/>
+            </a:pPr>
+            <a:r>
+              <a:rPr lang="en-US" sz="1500" b="1" dirty="0">
+                <a:solidFill>
+                  <a:srgbClr val="E8590C"/>
+                </a:solidFill>
+                <a:latin typeface="Calibri" pitchFamily="34" charset="0"/>
+                <a:ea typeface="Calibri" pitchFamily="34" charset="-122"/>
+                <a:cs typeface="Calibri" pitchFamily="34" charset="-120"/>
+              </a:rPr>
+              <a:t>Same classes, opposite registration order, different application. There is a test for it.</a:t>
+            </a:r>
+            <a:endParaRPr lang="en-US" sz="1500" dirty="0"/>
+          </a:p>
+        </p:txBody>
+      </p:sp>
+    </p:spTree>
+  </p:cSld>
+  <p:clrMapOvr>
+    <a:masterClrMapping/>
+  </p:clrMapOvr>
+</p:sld>
+</file>
+
+<file path=ppt/slides/slide36.xml><?xml version="1.0" encoding="utf-8"?>
+<p:sld xmlns:a="http://schemas.openxmlformats.org/drawingml/2006/main" xmlns:r="http://schemas.openxmlformats.org/officeDocument/2006/relationships" xmlns:p="http://schemas.openxmlformats.org/presentationml/2006/main">
+  <p:cSld name="Slide 36">
+    <p:bg>
+      <p:bgPr>
+        <a:solidFill>
+          <a:srgbClr val="FFFFFF"/>
+        </a:solidFill>
+      </p:bgPr>
+    </p:bg>
+    <p:spTree>
+      <p:nvGrpSpPr>
+        <p:cNvPr id="1" name=""/>
+        <p:cNvGrpSpPr/>
+        <p:nvPr/>
+      </p:nvGrpSpPr>
+      <p:grpSpPr>
+        <a:xfrm>
+          <a:off x="0" y="0"/>
+          <a:ext cx="0" cy="0"/>
+          <a:chOff x="0" y="0"/>
+          <a:chExt cx="0" cy="0"/>
+        </a:xfrm>
+      </p:grpSpPr>
+      <p:sp>
+        <p:nvSpPr>
+          <p:cNvPr id="2" name="Text 0"/>
+          <p:cNvSpPr txBox="1"/>
+          <p:nvPr/>
+        </p:nvSpPr>
+        <p:spPr>
+          <a:xfrm>
+            <a:off x="457200" y="292608"/>
+            <a:ext cx="8229600" cy="713232"/>
+          </a:xfrm>
+          <a:prstGeom prst="rect">
+            <a:avLst/>
+          </a:prstGeom>
+          <a:noFill/>
+          <a:ln/>
+        </p:spPr>
+        <p:txBody>
+          <a:bodyPr wrap="square" lIns="0" tIns="0" rIns="0" bIns="0" rtlCol="0" anchor="t"/>
+          <a:lstStyle/>
+          <a:p>
+            <a:pPr indent="0" marL="0">
+              <a:buNone/>
+            </a:pPr>
+            <a:r>
+              <a:rPr lang="en-US" sz="3000" b="1" dirty="0">
+                <a:solidFill>
+                  <a:srgbClr val="22303C"/>
+                </a:solidFill>
+                <a:latin typeface="Cambria" pitchFamily="34" charset="0"/>
+                <a:ea typeface="Cambria" pitchFamily="34" charset="-122"/>
+                <a:cs typeface="Cambria" pitchFamily="34" charset="-120"/>
+              </a:rPr>
               <a:t>"Why is my bean not there?"</a:t>
             </a:r>
             <a:endParaRPr lang="en-US" sz="3000" dirty="0"/>
@@ -21235,9 +22784,9 @@
 </p:sld>
 </file>
 
-<file path=ppt/slides/slide36.xml><?xml version="1.0" encoding="utf-8"?>
+<file path=ppt/slides/slide37.xml><?xml version="1.0" encoding="utf-8"?>
 <p:sld xmlns:a="http://schemas.openxmlformats.org/drawingml/2006/main" xmlns:r="http://schemas.openxmlformats.org/officeDocument/2006/relationships" xmlns:p="http://schemas.openxmlformats.org/presentationml/2006/main">
-  <p:cSld name="Slide 36">
+  <p:cSld name="Slide 37">
     <p:bg>
       <p:bgPr>
         <a:solidFill>
@@ -21404,9 +22953,9 @@
 </p:sld>
 </file>
 
-<file path=ppt/slides/slide37.xml><?xml version="1.0" encoding="utf-8"?>
+<file path=ppt/slides/slide38.xml><?xml version="1.0" encoding="utf-8"?>
 <p:sld xmlns:a="http://schemas.openxmlformats.org/drawingml/2006/main" xmlns:r="http://schemas.openxmlformats.org/officeDocument/2006/relationships" xmlns:p="http://schemas.openxmlformats.org/presentationml/2006/main">
-  <p:cSld name="Slide 37">
+  <p:cSld name="Slide 38">
     <p:bg>
       <p:bgPr>
         <a:solidFill>
@@ -21508,7 +23057,7 @@
       </p:sp>
       <p:graphicFrame>
         <p:nvGraphicFramePr>
-          <p:cNvPr id="38" name="Table 0"/>
+          <p:cNvPr id="39" name="Table 0"/>
           <p:cNvGraphicFramePr>
             <a:graphicFrameLocks noGrp="1"/>
           </p:cNvGraphicFramePr>
@@ -22408,9 +23957,9 @@
 </p:sld>
 </file>
 
-<file path=ppt/slides/slide38.xml><?xml version="1.0" encoding="utf-8"?>
+<file path=ppt/slides/slide39.xml><?xml version="1.0" encoding="utf-8"?>
 <p:sld xmlns:a="http://schemas.openxmlformats.org/drawingml/2006/main" xmlns:r="http://schemas.openxmlformats.org/officeDocument/2006/relationships" xmlns:p="http://schemas.openxmlformats.org/presentationml/2006/main">
-  <p:cSld name="Slide 38">
+  <p:cSld name="Slide 39">
     <p:bg>
       <p:bgPr>
         <a:solidFill>

</xml_diff>